<commit_message>
defense deck: add robustness and limitations slides (S13-S14)
- Robustness (S13): cost sensitivity table across 3 scenarios + cost_sensitivity.png
- Limitations (S14): 6 points in 2-column layout (ERA5 bound, walk-forward, EUA, XGBoost tuning, France-only, market impact)
- Conclusions shifted to S15, Thank You to S16 — total 16 slides
- Also commit make_presentation.py and Soutenance_FR_Power_Prices.pptx (alternative deck built earlier)

Co-Authored-By: Claude Sonnet 4.6 <noreply@anthropic.com>
</commit_message>
<xml_diff>
--- a/outputs/Defense_Presentation.pptx
+++ b/outputs/Defense_Presentation.pptx
@@ -19,6 +19,8 @@
     <p:sldId id="267" r:id="rId18"/>
     <p:sldId id="268" r:id="rId19"/>
     <p:sldId id="269" r:id="rId20"/>
+    <p:sldId id="270" r:id="rId21"/>
+    <p:sldId id="271" r:id="rId22"/>
   </p:sldIdLst>
   <p:sldSz cx="12191695" cy="6858000" type="screen4x3"/>
   <p:notesSz cx="6858000" cy="9144000"/>
@@ -6794,7 +6796,7 @@
                 </a:solidFill>
                 <a:latin typeface="Calibri"/>
               </a:rPr>
-              <a:t>CONCLUSIONS</a:t>
+              <a:t>ROBUSTNESS CHECKS</a:t>
             </a:r>
           </a:p>
         </p:txBody>
@@ -6829,7 +6831,7 @@
                 </a:solidFill>
                 <a:latin typeface="Calibri"/>
               </a:rPr>
-              <a:t>Four takeaways</a:t>
+              <a:t>The result holds under different assumptions</a:t>
             </a:r>
           </a:p>
         </p:txBody>
@@ -6915,14 +6917,49 @@
       </p:sp>
       <p:sp>
         <p:nvSpPr>
-          <p:cNvPr id="8" name="Rectangle 7"/>
+          <p:cNvPr id="8" name="TextBox 7"/>
+          <p:cNvSpPr txBox="1"/>
+          <p:nvPr/>
+        </p:nvSpPr>
+        <p:spPr>
+          <a:xfrm>
+            <a:off x="502920" y="1234440"/>
+            <a:ext cx="5303520" cy="457200"/>
+          </a:xfrm>
+          <a:prstGeom prst="rect">
+            <a:avLst/>
+          </a:prstGeom>
+          <a:noFill/>
+        </p:spPr>
+        <p:txBody>
+          <a:bodyPr wrap="square" anchor="t">
+            <a:spAutoFit/>
+          </a:bodyPr>
+          <a:lstStyle/>
+          <a:p>
+            <a:pPr algn="l"/>
+            <a:r>
+              <a:rPr sz="1400" b="1" i="0">
+                <a:solidFill>
+                  <a:srgbClr val="003E7E"/>
+                </a:solidFill>
+                <a:latin typeface="Calibri"/>
+              </a:rPr>
+              <a:t>Cost sensitivity — Net P&amp;L (EUR/MW)</a:t>
+            </a:r>
+          </a:p>
+        </p:txBody>
+      </p:sp>
+      <p:sp>
+        <p:nvSpPr>
+          <p:cNvPr id="9" name="Rectangle 8"/>
           <p:cNvSpPr/>
           <p:nvPr/>
         </p:nvSpPr>
         <p:spPr>
           <a:xfrm>
-            <a:off x="640080" y="1371600"/>
-            <a:ext cx="548640" cy="1051560"/>
+            <a:off x="502920" y="1783080"/>
+            <a:ext cx="5303520" cy="512064"/>
           </a:xfrm>
           <a:prstGeom prst="rect">
             <a:avLst/>
@@ -6959,14 +6996,14 @@
       </p:sp>
       <p:sp>
         <p:nvSpPr>
-          <p:cNvPr id="9" name="TextBox 8"/>
-          <p:cNvSpPr txBox="1"/>
-          <p:nvPr/>
-        </p:nvSpPr>
-        <p:spPr>
-          <a:xfrm>
-            <a:off x="640080" y="1371600"/>
-            <a:ext cx="548640" cy="1051560"/>
+          <p:cNvPr id="10" name="TextBox 9"/>
+          <p:cNvSpPr txBox="1"/>
+          <p:nvPr/>
+        </p:nvSpPr>
+        <p:spPr>
+          <a:xfrm>
+            <a:off x="566928" y="1783080"/>
+            <a:ext cx="1627632" cy="512064"/>
           </a:xfrm>
           <a:prstGeom prst="rect">
             <a:avLst/>
@@ -6979,29 +7016,134 @@
           </a:bodyPr>
           <a:lstStyle/>
           <a:p>
-            <a:pPr algn="ctr"/>
-            <a:r>
-              <a:rPr sz="2400" b="1" i="0">
+            <a:pPr algn="l"/>
+            <a:r>
+              <a:rPr sz="1200" b="1" i="0">
                 <a:solidFill>
                   <a:srgbClr val="FFFFFF"/>
                 </a:solidFill>
                 <a:latin typeface="Calibri"/>
               </a:rPr>
-              <a:t>1</a:t>
-            </a:r>
-          </a:p>
-        </p:txBody>
-      </p:sp>
-      <p:sp>
-        <p:nvSpPr>
-          <p:cNvPr id="10" name="Rectangle 9"/>
+              <a:t>Model</a:t>
+            </a:r>
+          </a:p>
+        </p:txBody>
+      </p:sp>
+      <p:sp>
+        <p:nvSpPr>
+          <p:cNvPr id="11" name="TextBox 10"/>
+          <p:cNvSpPr txBox="1"/>
+          <p:nvPr/>
+        </p:nvSpPr>
+        <p:spPr>
+          <a:xfrm>
+            <a:off x="2258568" y="1783080"/>
+            <a:ext cx="1143000" cy="512064"/>
+          </a:xfrm>
+          <a:prstGeom prst="rect">
+            <a:avLst/>
+          </a:prstGeom>
+          <a:noFill/>
+        </p:spPr>
+        <p:txBody>
+          <a:bodyPr wrap="square" anchor="ctr">
+            <a:spAutoFit/>
+          </a:bodyPr>
+          <a:lstStyle/>
+          <a:p>
+            <a:pPr algn="ctr"/>
+            <a:r>
+              <a:rPr sz="1200" b="1" i="0">
+                <a:solidFill>
+                  <a:srgbClr val="FFFFFF"/>
+                </a:solidFill>
+                <a:latin typeface="Calibri"/>
+              </a:rPr>
+              <a:t>0.10 EUR/MWh</a:t>
+            </a:r>
+          </a:p>
+        </p:txBody>
+      </p:sp>
+      <p:sp>
+        <p:nvSpPr>
+          <p:cNvPr id="12" name="TextBox 11"/>
+          <p:cNvSpPr txBox="1"/>
+          <p:nvPr/>
+        </p:nvSpPr>
+        <p:spPr>
+          <a:xfrm>
+            <a:off x="3465576" y="1783080"/>
+            <a:ext cx="1143000" cy="512064"/>
+          </a:xfrm>
+          <a:prstGeom prst="rect">
+            <a:avLst/>
+          </a:prstGeom>
+          <a:noFill/>
+        </p:spPr>
+        <p:txBody>
+          <a:bodyPr wrap="square" anchor="ctr">
+            <a:spAutoFit/>
+          </a:bodyPr>
+          <a:lstStyle/>
+          <a:p>
+            <a:pPr algn="ctr"/>
+            <a:r>
+              <a:rPr sz="1200" b="1" i="0">
+                <a:solidFill>
+                  <a:srgbClr val="FFFFFF"/>
+                </a:solidFill>
+                <a:latin typeface="Calibri"/>
+              </a:rPr>
+              <a:t>0.30 EUR/MWh</a:t>
+            </a:r>
+          </a:p>
+        </p:txBody>
+      </p:sp>
+      <p:sp>
+        <p:nvSpPr>
+          <p:cNvPr id="13" name="TextBox 12"/>
+          <p:cNvSpPr txBox="1"/>
+          <p:nvPr/>
+        </p:nvSpPr>
+        <p:spPr>
+          <a:xfrm>
+            <a:off x="4672584" y="1783080"/>
+            <a:ext cx="1133856" cy="512064"/>
+          </a:xfrm>
+          <a:prstGeom prst="rect">
+            <a:avLst/>
+          </a:prstGeom>
+          <a:noFill/>
+        </p:spPr>
+        <p:txBody>
+          <a:bodyPr wrap="square" anchor="ctr">
+            <a:spAutoFit/>
+          </a:bodyPr>
+          <a:lstStyle/>
+          <a:p>
+            <a:pPr algn="ctr"/>
+            <a:r>
+              <a:rPr sz="1200" b="1" i="0">
+                <a:solidFill>
+                  <a:srgbClr val="FFFFFF"/>
+                </a:solidFill>
+                <a:latin typeface="Calibri"/>
+              </a:rPr>
+              <a:t>0.60 EUR/MWh</a:t>
+            </a:r>
+          </a:p>
+        </p:txBody>
+      </p:sp>
+      <p:sp>
+        <p:nvSpPr>
+          <p:cNvPr id="14" name="Rectangle 13"/>
           <p:cNvSpPr/>
           <p:nvPr/>
         </p:nvSpPr>
         <p:spPr>
           <a:xfrm>
-            <a:off x="1325880" y="1371600"/>
-            <a:ext cx="10195560" cy="1051560"/>
+            <a:off x="502920" y="2295144"/>
+            <a:ext cx="5303520" cy="512064"/>
           </a:xfrm>
           <a:prstGeom prst="rect">
             <a:avLst/>
@@ -7038,71 +7180,160 @@
       </p:sp>
       <p:sp>
         <p:nvSpPr>
-          <p:cNvPr id="11" name="TextBox 10"/>
-          <p:cNvSpPr txBox="1"/>
-          <p:nvPr/>
-        </p:nvSpPr>
-        <p:spPr>
-          <a:xfrm>
-            <a:off x="1600200" y="1463040"/>
-            <a:ext cx="9784080" cy="914400"/>
-          </a:xfrm>
-          <a:prstGeom prst="rect">
-            <a:avLst/>
-          </a:prstGeom>
-          <a:noFill/>
-        </p:spPr>
-        <p:txBody>
-          <a:bodyPr wrap="square" anchor="t">
+          <p:cNvPr id="15" name="TextBox 14"/>
+          <p:cNvSpPr txBox="1"/>
+          <p:nvPr/>
+        </p:nvSpPr>
+        <p:spPr>
+          <a:xfrm>
+            <a:off x="566928" y="2295144"/>
+            <a:ext cx="1627632" cy="512064"/>
+          </a:xfrm>
+          <a:prstGeom prst="rect">
+            <a:avLst/>
+          </a:prstGeom>
+          <a:noFill/>
+        </p:spPr>
+        <p:txBody>
+          <a:bodyPr wrap="square" anchor="ctr">
             <a:spAutoFit/>
           </a:bodyPr>
           <a:lstStyle/>
           <a:p>
             <a:pPr algn="l"/>
             <a:r>
-              <a:rPr sz="1700" b="1" i="0">
-                <a:solidFill>
-                  <a:srgbClr val="003E7E"/>
-                </a:solidFill>
-                <a:latin typeface="Calibri"/>
-              </a:rPr>
-              <a:t>ML beats naïve, decisively</a:t>
-            </a:r>
-          </a:p>
-          <a:p>
-            <a:pPr algn="l">
-              <a:spcBef>
-                <a:spcPts val="200"/>
-              </a:spcBef>
-            </a:pPr>
-            <a:r>
-              <a:rPr sz="1400" b="0" i="0">
+              <a:rPr sz="1200" b="1" i="0">
                 <a:solidFill>
                   <a:srgbClr val="212529"/>
                 </a:solidFill>
                 <a:latin typeface="Calibri"/>
               </a:rPr>
-              <a:t>−49% MAE, R² 0.78, p &lt; 0.001 — robust across all 12 months.</a:t>
-            </a:r>
-          </a:p>
-        </p:txBody>
-      </p:sp>
-      <p:sp>
-        <p:nvSpPr>
-          <p:cNvPr id="12" name="Rectangle 11"/>
+              <a:t>A — Naïve</a:t>
+            </a:r>
+          </a:p>
+        </p:txBody>
+      </p:sp>
+      <p:sp>
+        <p:nvSpPr>
+          <p:cNvPr id="16" name="TextBox 15"/>
+          <p:cNvSpPr txBox="1"/>
+          <p:nvPr/>
+        </p:nvSpPr>
+        <p:spPr>
+          <a:xfrm>
+            <a:off x="2258568" y="2295144"/>
+            <a:ext cx="1143000" cy="512064"/>
+          </a:xfrm>
+          <a:prstGeom prst="rect">
+            <a:avLst/>
+          </a:prstGeom>
+          <a:noFill/>
+        </p:spPr>
+        <p:txBody>
+          <a:bodyPr wrap="square" anchor="ctr">
+            <a:spAutoFit/>
+          </a:bodyPr>
+          <a:lstStyle/>
+          <a:p>
+            <a:pPr algn="ctr"/>
+            <a:r>
+              <a:rPr sz="1200" b="0" i="0">
+                <a:solidFill>
+                  <a:srgbClr val="212529"/>
+                </a:solidFill>
+                <a:latin typeface="Calibri"/>
+              </a:rPr>
+              <a:t>88,340</a:t>
+            </a:r>
+          </a:p>
+        </p:txBody>
+      </p:sp>
+      <p:sp>
+        <p:nvSpPr>
+          <p:cNvPr id="17" name="TextBox 16"/>
+          <p:cNvSpPr txBox="1"/>
+          <p:nvPr/>
+        </p:nvSpPr>
+        <p:spPr>
+          <a:xfrm>
+            <a:off x="3465576" y="2295144"/>
+            <a:ext cx="1143000" cy="512064"/>
+          </a:xfrm>
+          <a:prstGeom prst="rect">
+            <a:avLst/>
+          </a:prstGeom>
+          <a:noFill/>
+        </p:spPr>
+        <p:txBody>
+          <a:bodyPr wrap="square" anchor="ctr">
+            <a:spAutoFit/>
+          </a:bodyPr>
+          <a:lstStyle/>
+          <a:p>
+            <a:pPr algn="ctr"/>
+            <a:r>
+              <a:rPr sz="1200" b="0" i="0">
+                <a:solidFill>
+                  <a:srgbClr val="212529"/>
+                </a:solidFill>
+                <a:latin typeface="Calibri"/>
+              </a:rPr>
+              <a:t>85,482</a:t>
+            </a:r>
+          </a:p>
+        </p:txBody>
+      </p:sp>
+      <p:sp>
+        <p:nvSpPr>
+          <p:cNvPr id="18" name="TextBox 17"/>
+          <p:cNvSpPr txBox="1"/>
+          <p:nvPr/>
+        </p:nvSpPr>
+        <p:spPr>
+          <a:xfrm>
+            <a:off x="4672584" y="2295144"/>
+            <a:ext cx="1133856" cy="512064"/>
+          </a:xfrm>
+          <a:prstGeom prst="rect">
+            <a:avLst/>
+          </a:prstGeom>
+          <a:noFill/>
+        </p:spPr>
+        <p:txBody>
+          <a:bodyPr wrap="square" anchor="ctr">
+            <a:spAutoFit/>
+          </a:bodyPr>
+          <a:lstStyle/>
+          <a:p>
+            <a:pPr algn="ctr"/>
+            <a:r>
+              <a:rPr sz="1200" b="0" i="0">
+                <a:solidFill>
+                  <a:srgbClr val="212529"/>
+                </a:solidFill>
+                <a:latin typeface="Calibri"/>
+              </a:rPr>
+              <a:t>81,195</a:t>
+            </a:r>
+          </a:p>
+        </p:txBody>
+      </p:sp>
+      <p:sp>
+        <p:nvSpPr>
+          <p:cNvPr id="19" name="Rectangle 18"/>
           <p:cNvSpPr/>
           <p:nvPr/>
         </p:nvSpPr>
         <p:spPr>
           <a:xfrm>
-            <a:off x="640080" y="2596896"/>
-            <a:ext cx="548640" cy="1051560"/>
+            <a:off x="502920" y="2807208"/>
+            <a:ext cx="5303520" cy="512064"/>
           </a:xfrm>
           <a:prstGeom prst="rect">
             <a:avLst/>
           </a:prstGeom>
           <a:solidFill>
-            <a:srgbClr val="003E7E"/>
+            <a:srgbClr val="FFFFFF"/>
           </a:solidFill>
           <a:ln>
             <a:noFill/>
@@ -7133,14 +7364,14 @@
       </p:sp>
       <p:sp>
         <p:nvSpPr>
-          <p:cNvPr id="13" name="TextBox 12"/>
-          <p:cNvSpPr txBox="1"/>
-          <p:nvPr/>
-        </p:nvSpPr>
-        <p:spPr>
-          <a:xfrm>
-            <a:off x="640080" y="2596896"/>
-            <a:ext cx="548640" cy="1051560"/>
+          <p:cNvPr id="20" name="TextBox 19"/>
+          <p:cNvSpPr txBox="1"/>
+          <p:nvPr/>
+        </p:nvSpPr>
+        <p:spPr>
+          <a:xfrm>
+            <a:off x="566928" y="2807208"/>
+            <a:ext cx="1627632" cy="512064"/>
           </a:xfrm>
           <a:prstGeom prst="rect">
             <a:avLst/>
@@ -7153,35 +7384,140 @@
           </a:bodyPr>
           <a:lstStyle/>
           <a:p>
-            <a:pPr algn="ctr"/>
-            <a:r>
-              <a:rPr sz="2400" b="1" i="0">
-                <a:solidFill>
-                  <a:srgbClr val="FFFFFF"/>
-                </a:solidFill>
-                <a:latin typeface="Calibri"/>
-              </a:rPr>
-              <a:t>2</a:t>
-            </a:r>
-          </a:p>
-        </p:txBody>
-      </p:sp>
-      <p:sp>
-        <p:nvSpPr>
-          <p:cNvPr id="14" name="Rectangle 13"/>
+            <a:pPr algn="l"/>
+            <a:r>
+              <a:rPr sz="1200" b="1" i="0">
+                <a:solidFill>
+                  <a:srgbClr val="212529"/>
+                </a:solidFill>
+                <a:latin typeface="Calibri"/>
+              </a:rPr>
+              <a:t>B — RF no wx</a:t>
+            </a:r>
+          </a:p>
+        </p:txBody>
+      </p:sp>
+      <p:sp>
+        <p:nvSpPr>
+          <p:cNvPr id="21" name="TextBox 20"/>
+          <p:cNvSpPr txBox="1"/>
+          <p:nvPr/>
+        </p:nvSpPr>
+        <p:spPr>
+          <a:xfrm>
+            <a:off x="2258568" y="2807208"/>
+            <a:ext cx="1143000" cy="512064"/>
+          </a:xfrm>
+          <a:prstGeom prst="rect">
+            <a:avLst/>
+          </a:prstGeom>
+          <a:noFill/>
+        </p:spPr>
+        <p:txBody>
+          <a:bodyPr wrap="square" anchor="ctr">
+            <a:spAutoFit/>
+          </a:bodyPr>
+          <a:lstStyle/>
+          <a:p>
+            <a:pPr algn="ctr"/>
+            <a:r>
+              <a:rPr sz="1200" b="0" i="0">
+                <a:solidFill>
+                  <a:srgbClr val="212529"/>
+                </a:solidFill>
+                <a:latin typeface="Calibri"/>
+              </a:rPr>
+              <a:t>139,742</a:t>
+            </a:r>
+          </a:p>
+        </p:txBody>
+      </p:sp>
+      <p:sp>
+        <p:nvSpPr>
+          <p:cNvPr id="22" name="TextBox 21"/>
+          <p:cNvSpPr txBox="1"/>
+          <p:nvPr/>
+        </p:nvSpPr>
+        <p:spPr>
+          <a:xfrm>
+            <a:off x="3465576" y="2807208"/>
+            <a:ext cx="1143000" cy="512064"/>
+          </a:xfrm>
+          <a:prstGeom prst="rect">
+            <a:avLst/>
+          </a:prstGeom>
+          <a:noFill/>
+        </p:spPr>
+        <p:txBody>
+          <a:bodyPr wrap="square" anchor="ctr">
+            <a:spAutoFit/>
+          </a:bodyPr>
+          <a:lstStyle/>
+          <a:p>
+            <a:pPr algn="ctr"/>
+            <a:r>
+              <a:rPr sz="1200" b="0" i="0">
+                <a:solidFill>
+                  <a:srgbClr val="212529"/>
+                </a:solidFill>
+                <a:latin typeface="Calibri"/>
+              </a:rPr>
+              <a:t>136,884</a:t>
+            </a:r>
+          </a:p>
+        </p:txBody>
+      </p:sp>
+      <p:sp>
+        <p:nvSpPr>
+          <p:cNvPr id="23" name="TextBox 22"/>
+          <p:cNvSpPr txBox="1"/>
+          <p:nvPr/>
+        </p:nvSpPr>
+        <p:spPr>
+          <a:xfrm>
+            <a:off x="4672584" y="2807208"/>
+            <a:ext cx="1133856" cy="512064"/>
+          </a:xfrm>
+          <a:prstGeom prst="rect">
+            <a:avLst/>
+          </a:prstGeom>
+          <a:noFill/>
+        </p:spPr>
+        <p:txBody>
+          <a:bodyPr wrap="square" anchor="ctr">
+            <a:spAutoFit/>
+          </a:bodyPr>
+          <a:lstStyle/>
+          <a:p>
+            <a:pPr algn="ctr"/>
+            <a:r>
+              <a:rPr sz="1200" b="0" i="0">
+                <a:solidFill>
+                  <a:srgbClr val="212529"/>
+                </a:solidFill>
+                <a:latin typeface="Calibri"/>
+              </a:rPr>
+              <a:t>132,597</a:t>
+            </a:r>
+          </a:p>
+        </p:txBody>
+      </p:sp>
+      <p:sp>
+        <p:nvSpPr>
+          <p:cNvPr id="24" name="Rectangle 23"/>
           <p:cNvSpPr/>
           <p:nvPr/>
         </p:nvSpPr>
         <p:spPr>
           <a:xfrm>
-            <a:off x="1325880" y="2596896"/>
-            <a:ext cx="10195560" cy="1051560"/>
+            <a:off x="502920" y="3319272"/>
+            <a:ext cx="5303520" cy="512064"/>
           </a:xfrm>
           <a:prstGeom prst="rect">
             <a:avLst/>
           </a:prstGeom>
           <a:solidFill>
-            <a:srgbClr val="EEF3F9"/>
+            <a:srgbClr val="D6E8F0"/>
           </a:solidFill>
           <a:ln>
             <a:noFill/>
@@ -7212,71 +7548,160 @@
       </p:sp>
       <p:sp>
         <p:nvSpPr>
-          <p:cNvPr id="15" name="TextBox 14"/>
-          <p:cNvSpPr txBox="1"/>
-          <p:nvPr/>
-        </p:nvSpPr>
-        <p:spPr>
-          <a:xfrm>
-            <a:off x="1600200" y="2688336"/>
-            <a:ext cx="9784080" cy="914400"/>
-          </a:xfrm>
-          <a:prstGeom prst="rect">
-            <a:avLst/>
-          </a:prstGeom>
-          <a:noFill/>
-        </p:spPr>
-        <p:txBody>
-          <a:bodyPr wrap="square" anchor="t">
+          <p:cNvPr id="25" name="TextBox 24"/>
+          <p:cNvSpPr txBox="1"/>
+          <p:nvPr/>
+        </p:nvSpPr>
+        <p:spPr>
+          <a:xfrm>
+            <a:off x="566928" y="3319272"/>
+            <a:ext cx="1627632" cy="512064"/>
+          </a:xfrm>
+          <a:prstGeom prst="rect">
+            <a:avLst/>
+          </a:prstGeom>
+          <a:noFill/>
+        </p:spPr>
+        <p:txBody>
+          <a:bodyPr wrap="square" anchor="ctr">
             <a:spAutoFit/>
           </a:bodyPr>
           <a:lstStyle/>
           <a:p>
             <a:pPr algn="l"/>
             <a:r>
-              <a:rPr sz="1700" b="1" i="0">
+              <a:rPr sz="1200" b="1" i="0">
                 <a:solidFill>
                   <a:srgbClr val="003E7E"/>
                 </a:solidFill>
                 <a:latin typeface="Calibri"/>
               </a:rPr>
-              <a:t>Weather is regime-dependent</a:t>
-            </a:r>
-          </a:p>
-          <a:p>
-            <a:pPr algn="l">
-              <a:spcBef>
-                <a:spcPts val="200"/>
-              </a:spcBef>
-            </a:pPr>
-            <a:r>
-              <a:rPr sz="1400" b="0" i="0">
-                <a:solidFill>
-                  <a:srgbClr val="212529"/>
-                </a:solidFill>
-                <a:latin typeface="Calibri"/>
-              </a:rPr>
-              <a:t>n.s. in the stable regime (redundancy), but significant in the 2022 crisis (redundancy breaks). The core contribution.</a:t>
-            </a:r>
-          </a:p>
-        </p:txBody>
-      </p:sp>
-      <p:sp>
-        <p:nvSpPr>
-          <p:cNvPr id="16" name="Rectangle 15"/>
+              <a:t>C — RF wx</a:t>
+            </a:r>
+          </a:p>
+        </p:txBody>
+      </p:sp>
+      <p:sp>
+        <p:nvSpPr>
+          <p:cNvPr id="26" name="TextBox 25"/>
+          <p:cNvSpPr txBox="1"/>
+          <p:nvPr/>
+        </p:nvSpPr>
+        <p:spPr>
+          <a:xfrm>
+            <a:off x="2258568" y="3319272"/>
+            <a:ext cx="1143000" cy="512064"/>
+          </a:xfrm>
+          <a:prstGeom prst="rect">
+            <a:avLst/>
+          </a:prstGeom>
+          <a:noFill/>
+        </p:spPr>
+        <p:txBody>
+          <a:bodyPr wrap="square" anchor="ctr">
+            <a:spAutoFit/>
+          </a:bodyPr>
+          <a:lstStyle/>
+          <a:p>
+            <a:pPr algn="ctr"/>
+            <a:r>
+              <a:rPr sz="1200" b="1" i="0">
+                <a:solidFill>
+                  <a:srgbClr val="003E7E"/>
+                </a:solidFill>
+                <a:latin typeface="Calibri"/>
+              </a:rPr>
+              <a:t>139,569</a:t>
+            </a:r>
+          </a:p>
+        </p:txBody>
+      </p:sp>
+      <p:sp>
+        <p:nvSpPr>
+          <p:cNvPr id="27" name="TextBox 26"/>
+          <p:cNvSpPr txBox="1"/>
+          <p:nvPr/>
+        </p:nvSpPr>
+        <p:spPr>
+          <a:xfrm>
+            <a:off x="3465576" y="3319272"/>
+            <a:ext cx="1143000" cy="512064"/>
+          </a:xfrm>
+          <a:prstGeom prst="rect">
+            <a:avLst/>
+          </a:prstGeom>
+          <a:noFill/>
+        </p:spPr>
+        <p:txBody>
+          <a:bodyPr wrap="square" anchor="ctr">
+            <a:spAutoFit/>
+          </a:bodyPr>
+          <a:lstStyle/>
+          <a:p>
+            <a:pPr algn="ctr"/>
+            <a:r>
+              <a:rPr sz="1200" b="1" i="0">
+                <a:solidFill>
+                  <a:srgbClr val="003E7E"/>
+                </a:solidFill>
+                <a:latin typeface="Calibri"/>
+              </a:rPr>
+              <a:t>136,711</a:t>
+            </a:r>
+          </a:p>
+        </p:txBody>
+      </p:sp>
+      <p:sp>
+        <p:nvSpPr>
+          <p:cNvPr id="28" name="TextBox 27"/>
+          <p:cNvSpPr txBox="1"/>
+          <p:nvPr/>
+        </p:nvSpPr>
+        <p:spPr>
+          <a:xfrm>
+            <a:off x="4672584" y="3319272"/>
+            <a:ext cx="1133856" cy="512064"/>
+          </a:xfrm>
+          <a:prstGeom prst="rect">
+            <a:avLst/>
+          </a:prstGeom>
+          <a:noFill/>
+        </p:spPr>
+        <p:txBody>
+          <a:bodyPr wrap="square" anchor="ctr">
+            <a:spAutoFit/>
+          </a:bodyPr>
+          <a:lstStyle/>
+          <a:p>
+            <a:pPr algn="ctr"/>
+            <a:r>
+              <a:rPr sz="1200" b="1" i="0">
+                <a:solidFill>
+                  <a:srgbClr val="003E7E"/>
+                </a:solidFill>
+                <a:latin typeface="Calibri"/>
+              </a:rPr>
+              <a:t>132,424</a:t>
+            </a:r>
+          </a:p>
+        </p:txBody>
+      </p:sp>
+      <p:sp>
+        <p:nvSpPr>
+          <p:cNvPr id="29" name="Rectangle 28"/>
           <p:cNvSpPr/>
           <p:nvPr/>
         </p:nvSpPr>
         <p:spPr>
           <a:xfrm>
-            <a:off x="640080" y="3822192"/>
-            <a:ext cx="548640" cy="1051560"/>
+            <a:off x="502920" y="3831336"/>
+            <a:ext cx="5303520" cy="512064"/>
           </a:xfrm>
           <a:prstGeom prst="rect">
             <a:avLst/>
           </a:prstGeom>
           <a:solidFill>
-            <a:srgbClr val="003E7E"/>
+            <a:srgbClr val="FFFFFF"/>
           </a:solidFill>
           <a:ln>
             <a:noFill/>
@@ -7307,14 +7732,14 @@
       </p:sp>
       <p:sp>
         <p:nvSpPr>
-          <p:cNvPr id="17" name="TextBox 16"/>
-          <p:cNvSpPr txBox="1"/>
-          <p:nvPr/>
-        </p:nvSpPr>
-        <p:spPr>
-          <a:xfrm>
-            <a:off x="640080" y="3822192"/>
-            <a:ext cx="548640" cy="1051560"/>
+          <p:cNvPr id="30" name="TextBox 29"/>
+          <p:cNvSpPr txBox="1"/>
+          <p:nvPr/>
+        </p:nvSpPr>
+        <p:spPr>
+          <a:xfrm>
+            <a:off x="566928" y="3831336"/>
+            <a:ext cx="1627632" cy="512064"/>
           </a:xfrm>
           <a:prstGeom prst="rect">
             <a:avLst/>
@@ -7327,73 +7752,134 @@
           </a:bodyPr>
           <a:lstStyle/>
           <a:p>
-            <a:pPr algn="ctr"/>
-            <a:r>
-              <a:rPr sz="2400" b="1" i="0">
-                <a:solidFill>
-                  <a:srgbClr val="FFFFFF"/>
-                </a:solidFill>
-                <a:latin typeface="Calibri"/>
-              </a:rPr>
-              <a:t>3</a:t>
-            </a:r>
-          </a:p>
-        </p:txBody>
-      </p:sp>
-      <p:sp>
-        <p:nvSpPr>
-          <p:cNvPr id="18" name="Rectangle 17"/>
-          <p:cNvSpPr/>
-          <p:nvPr/>
-        </p:nvSpPr>
-        <p:spPr>
-          <a:xfrm>
-            <a:off x="1325880" y="3822192"/>
-            <a:ext cx="10195560" cy="1051560"/>
-          </a:xfrm>
-          <a:prstGeom prst="rect">
-            <a:avLst/>
-          </a:prstGeom>
-          <a:solidFill>
-            <a:srgbClr val="EEF3F9"/>
-          </a:solidFill>
-          <a:ln>
-            <a:noFill/>
-          </a:ln>
-          <a:effectLst/>
-        </p:spPr>
-        <p:style>
-          <a:lnRef idx="1">
-            <a:schemeClr val="accent1"/>
-          </a:lnRef>
-          <a:fillRef idx="3">
-            <a:schemeClr val="accent1"/>
-          </a:fillRef>
-          <a:effectRef idx="2">
-            <a:schemeClr val="accent1"/>
-          </a:effectRef>
-          <a:fontRef idx="minor">
-            <a:schemeClr val="lt1"/>
-          </a:fontRef>
-        </p:style>
-        <p:txBody>
-          <a:bodyPr rtlCol="0" anchor="ctr"/>
-          <a:lstStyle/>
-          <a:p>
-            <a:pPr algn="ctr"/>
-          </a:p>
-        </p:txBody>
-      </p:sp>
-      <p:sp>
-        <p:nvSpPr>
-          <p:cNvPr id="19" name="TextBox 18"/>
-          <p:cNvSpPr txBox="1"/>
-          <p:nvPr/>
-        </p:nvSpPr>
-        <p:spPr>
-          <a:xfrm>
-            <a:off x="1600200" y="3913632"/>
-            <a:ext cx="9784080" cy="914400"/>
+            <a:pPr algn="l"/>
+            <a:r>
+              <a:rPr sz="1200" b="1" i="0">
+                <a:solidFill>
+                  <a:srgbClr val="212529"/>
+                </a:solidFill>
+                <a:latin typeface="Calibri"/>
+              </a:rPr>
+              <a:t>D — XGBoost</a:t>
+            </a:r>
+          </a:p>
+        </p:txBody>
+      </p:sp>
+      <p:sp>
+        <p:nvSpPr>
+          <p:cNvPr id="31" name="TextBox 30"/>
+          <p:cNvSpPr txBox="1"/>
+          <p:nvPr/>
+        </p:nvSpPr>
+        <p:spPr>
+          <a:xfrm>
+            <a:off x="2258568" y="3831336"/>
+            <a:ext cx="1143000" cy="512064"/>
+          </a:xfrm>
+          <a:prstGeom prst="rect">
+            <a:avLst/>
+          </a:prstGeom>
+          <a:noFill/>
+        </p:spPr>
+        <p:txBody>
+          <a:bodyPr wrap="square" anchor="ctr">
+            <a:spAutoFit/>
+          </a:bodyPr>
+          <a:lstStyle/>
+          <a:p>
+            <a:pPr algn="ctr"/>
+            <a:r>
+              <a:rPr sz="1200" b="0" i="0">
+                <a:solidFill>
+                  <a:srgbClr val="212529"/>
+                </a:solidFill>
+                <a:latin typeface="Calibri"/>
+              </a:rPr>
+              <a:t>144,870</a:t>
+            </a:r>
+          </a:p>
+        </p:txBody>
+      </p:sp>
+      <p:sp>
+        <p:nvSpPr>
+          <p:cNvPr id="32" name="TextBox 31"/>
+          <p:cNvSpPr txBox="1"/>
+          <p:nvPr/>
+        </p:nvSpPr>
+        <p:spPr>
+          <a:xfrm>
+            <a:off x="3465576" y="3831336"/>
+            <a:ext cx="1143000" cy="512064"/>
+          </a:xfrm>
+          <a:prstGeom prst="rect">
+            <a:avLst/>
+          </a:prstGeom>
+          <a:noFill/>
+        </p:spPr>
+        <p:txBody>
+          <a:bodyPr wrap="square" anchor="ctr">
+            <a:spAutoFit/>
+          </a:bodyPr>
+          <a:lstStyle/>
+          <a:p>
+            <a:pPr algn="ctr"/>
+            <a:r>
+              <a:rPr sz="1200" b="0" i="0">
+                <a:solidFill>
+                  <a:srgbClr val="212529"/>
+                </a:solidFill>
+                <a:latin typeface="Calibri"/>
+              </a:rPr>
+              <a:t>142,012</a:t>
+            </a:r>
+          </a:p>
+        </p:txBody>
+      </p:sp>
+      <p:sp>
+        <p:nvSpPr>
+          <p:cNvPr id="33" name="TextBox 32"/>
+          <p:cNvSpPr txBox="1"/>
+          <p:nvPr/>
+        </p:nvSpPr>
+        <p:spPr>
+          <a:xfrm>
+            <a:off x="4672584" y="3831336"/>
+            <a:ext cx="1133856" cy="512064"/>
+          </a:xfrm>
+          <a:prstGeom prst="rect">
+            <a:avLst/>
+          </a:prstGeom>
+          <a:noFill/>
+        </p:spPr>
+        <p:txBody>
+          <a:bodyPr wrap="square" anchor="ctr">
+            <a:spAutoFit/>
+          </a:bodyPr>
+          <a:lstStyle/>
+          <a:p>
+            <a:pPr algn="ctr"/>
+            <a:r>
+              <a:rPr sz="1200" b="0" i="0">
+                <a:solidFill>
+                  <a:srgbClr val="212529"/>
+                </a:solidFill>
+                <a:latin typeface="Calibri"/>
+              </a:rPr>
+              <a:t>137,725</a:t>
+            </a:r>
+          </a:p>
+        </p:txBody>
+      </p:sp>
+      <p:sp>
+        <p:nvSpPr>
+          <p:cNvPr id="34" name="TextBox 33"/>
+          <p:cNvSpPr txBox="1"/>
+          <p:nvPr/>
+        </p:nvSpPr>
+        <p:spPr>
+          <a:xfrm>
+            <a:off x="502920" y="4663440"/>
+            <a:ext cx="5303520" cy="1463040"/>
           </a:xfrm>
           <a:prstGeom prst="rect">
             <a:avLst/>
@@ -7406,212 +7892,114 @@
           </a:bodyPr>
           <a:lstStyle/>
           <a:p>
+            <a:pPr algn="l">
+              <a:spcAft>
+                <a:spcPts val="600"/>
+              </a:spcAft>
+            </a:pPr>
+            <a:r>
+              <a:rPr sz="1400" b="1" i="0">
+                <a:solidFill>
+                  <a:srgbClr val="228B4C"/>
+                </a:solidFill>
+                <a:latin typeface="Calibri"/>
+              </a:rPr>
+              <a:t>RF Sharpe: 19.51 → 19.46 → 19.16</a:t>
+            </a:r>
+            <a:r>
+              <a:rPr sz="1300" b="0" i="0">
+                <a:solidFill>
+                  <a:srgbClr val="212529"/>
+                </a:solidFill>
+                <a:latin typeface="Calibri"/>
+              </a:rPr>
+              <a:t>  across all three cost scenarios</a:t>
+            </a:r>
+          </a:p>
+          <a:p>
+            <a:pPr algn="l">
+              <a:spcAft>
+                <a:spcPts val="600"/>
+              </a:spcAft>
+            </a:pPr>
+            <a:r>
+              <a:rPr sz="1300" b="0" i="0">
+                <a:solidFill>
+                  <a:srgbClr val="212529"/>
+                </a:solidFill>
+                <a:latin typeface="Calibri"/>
+              </a:rPr>
+              <a:t>Positive Sharpe in </a:t>
+            </a:r>
+            <a:r>
+              <a:rPr sz="1300" b="1" i="0">
+                <a:solidFill>
+                  <a:srgbClr val="003E7E"/>
+                </a:solidFill>
+                <a:latin typeface="Calibri"/>
+              </a:rPr>
+              <a:t>all 12 months</a:t>
+            </a:r>
+            <a:r>
+              <a:rPr sz="1300" b="0" i="0">
+                <a:solidFill>
+                  <a:srgbClr val="212529"/>
+                </a:solidFill>
+                <a:latin typeface="Calibri"/>
+              </a:rPr>
+              <a:t> of the test period</a:t>
+            </a:r>
+          </a:p>
+          <a:p>
             <a:pPr algn="l"/>
             <a:r>
-              <a:rPr sz="1700" b="1" i="0">
+              <a:rPr sz="1300" b="1" i="0">
                 <a:solidFill>
                   <a:srgbClr val="003E7E"/>
                 </a:solidFill>
                 <a:latin typeface="Calibri"/>
               </a:rPr>
-              <a:t>Random Forest &gt; XGBoost</a:t>
-            </a:r>
-          </a:p>
-          <a:p>
-            <a:pPr algn="l">
-              <a:spcBef>
-                <a:spcPts val="200"/>
-              </a:spcBef>
-            </a:pPr>
-            <a:r>
-              <a:rPr sz="1400" b="0" i="0">
+              <a:t>DM result stable: </a:t>
+            </a:r>
+            <a:r>
+              <a:rPr sz="1300" b="0" i="0">
                 <a:solidFill>
                   <a:srgbClr val="212529"/>
                 </a:solidFill>
                 <a:latin typeface="Calibri"/>
               </a:rPr>
-              <a:t>RF wins on risk-adjusted metrics (Calmar 328 vs 107) and degrades less under stress.</a:t>
-            </a:r>
-          </a:p>
-        </p:txBody>
-      </p:sp>
-      <p:sp>
-        <p:nvSpPr>
-          <p:cNvPr id="20" name="Rectangle 19"/>
-          <p:cNvSpPr/>
-          <p:nvPr/>
-        </p:nvSpPr>
-        <p:spPr>
-          <a:xfrm>
-            <a:off x="640080" y="5047488"/>
-            <a:ext cx="548640" cy="1051560"/>
-          </a:xfrm>
-          <a:prstGeom prst="rect">
-            <a:avLst/>
-          </a:prstGeom>
-          <a:solidFill>
-            <a:srgbClr val="003E7E"/>
-          </a:solidFill>
-          <a:ln>
-            <a:noFill/>
-          </a:ln>
-          <a:effectLst/>
-        </p:spPr>
-        <p:style>
-          <a:lnRef idx="1">
-            <a:schemeClr val="accent1"/>
-          </a:lnRef>
-          <a:fillRef idx="3">
-            <a:schemeClr val="accent1"/>
-          </a:fillRef>
-          <a:effectRef idx="2">
-            <a:schemeClr val="accent1"/>
-          </a:effectRef>
-          <a:fontRef idx="minor">
-            <a:schemeClr val="lt1"/>
-          </a:fontRef>
-        </p:style>
-        <p:txBody>
-          <a:bodyPr rtlCol="0" anchor="ctr"/>
-          <a:lstStyle/>
-          <a:p>
-            <a:pPr algn="ctr"/>
-          </a:p>
-        </p:txBody>
-      </p:sp>
-      <p:sp>
-        <p:nvSpPr>
-          <p:cNvPr id="21" name="TextBox 20"/>
-          <p:cNvSpPr txBox="1"/>
-          <p:nvPr/>
-        </p:nvSpPr>
-        <p:spPr>
-          <a:xfrm>
-            <a:off x="640080" y="5047488"/>
-            <a:ext cx="548640" cy="1051560"/>
-          </a:xfrm>
-          <a:prstGeom prst="rect">
-            <a:avLst/>
-          </a:prstGeom>
-          <a:noFill/>
-        </p:spPr>
-        <p:txBody>
-          <a:bodyPr wrap="square" anchor="ctr">
-            <a:spAutoFit/>
-          </a:bodyPr>
-          <a:lstStyle/>
-          <a:p>
-            <a:pPr algn="ctr"/>
-            <a:r>
-              <a:rPr sz="2400" b="1" i="0">
-                <a:solidFill>
-                  <a:srgbClr val="FFFFFF"/>
-                </a:solidFill>
-                <a:latin typeface="Calibri"/>
-              </a:rPr>
-              <a:t>4</a:t>
-            </a:r>
-          </a:p>
-        </p:txBody>
-      </p:sp>
-      <p:sp>
-        <p:nvSpPr>
-          <p:cNvPr id="22" name="Rectangle 21"/>
-          <p:cNvSpPr/>
-          <p:nvPr/>
-        </p:nvSpPr>
-        <p:spPr>
-          <a:xfrm>
-            <a:off x="1325880" y="5047488"/>
-            <a:ext cx="10195560" cy="1051560"/>
-          </a:xfrm>
-          <a:prstGeom prst="rect">
-            <a:avLst/>
-          </a:prstGeom>
-          <a:solidFill>
-            <a:srgbClr val="EEF3F9"/>
-          </a:solidFill>
-          <a:ln>
-            <a:noFill/>
-          </a:ln>
-          <a:effectLst/>
-        </p:spPr>
-        <p:style>
-          <a:lnRef idx="1">
-            <a:schemeClr val="accent1"/>
-          </a:lnRef>
-          <a:fillRef idx="3">
-            <a:schemeClr val="accent1"/>
-          </a:fillRef>
-          <a:effectRef idx="2">
-            <a:schemeClr val="accent1"/>
-          </a:effectRef>
-          <a:fontRef idx="minor">
-            <a:schemeClr val="lt1"/>
-          </a:fontRef>
-        </p:style>
-        <p:txBody>
-          <a:bodyPr rtlCol="0" anchor="ctr"/>
-          <a:lstStyle/>
-          <a:p>
-            <a:pPr algn="ctr"/>
-          </a:p>
-        </p:txBody>
-      </p:sp>
-      <p:sp>
-        <p:nvSpPr>
-          <p:cNvPr id="23" name="TextBox 22"/>
-          <p:cNvSpPr txBox="1"/>
-          <p:nvPr/>
-        </p:nvSpPr>
-        <p:spPr>
-          <a:xfrm>
-            <a:off x="1600200" y="5138928"/>
-            <a:ext cx="9784080" cy="914400"/>
-          </a:xfrm>
-          <a:prstGeom prst="rect">
-            <a:avLst/>
-          </a:prstGeom>
-          <a:noFill/>
-        </p:spPr>
-        <p:txBody>
-          <a:bodyPr wrap="square" anchor="t">
-            <a:spAutoFit/>
-          </a:bodyPr>
-          <a:lstStyle/>
-          <a:p>
-            <a:pPr algn="l"/>
-            <a:r>
-              <a:rPr sz="1700" b="1" i="0">
-                <a:solidFill>
-                  <a:srgbClr val="003E7E"/>
-                </a:solidFill>
-                <a:latin typeface="Calibri"/>
-              </a:rPr>
-              <a:t>Forecasts create real value</a:t>
-            </a:r>
-          </a:p>
-          <a:p>
-            <a:pPr algn="l">
-              <a:spcBef>
-                <a:spcPts val="200"/>
-              </a:spcBef>
-            </a:pPr>
-            <a:r>
-              <a:rPr sz="1400" b="0" i="0">
-                <a:solidFill>
-                  <a:srgbClr val="212529"/>
-                </a:solidFill>
-                <a:latin typeface="Calibri"/>
-              </a:rPr>
-              <a:t>~137k EUR/MW net, Sharpe ~19.5, tiny drawdown — robust to transaction costs.</a:t>
-            </a:r>
-          </a:p>
-        </p:txBody>
-      </p:sp>
-      <p:sp>
-        <p:nvSpPr>
-          <p:cNvPr id="24" name="TextBox 23"/>
+              <a:t>p = 0.572 n.s. confirmed across multiple sub-periods</a:t>
+            </a:r>
+          </a:p>
+        </p:txBody>
+      </p:sp>
+      <p:pic>
+        <p:nvPicPr>
+          <p:cNvPr id="35" name="Picture 34" descr="cost_sensitivity.png"/>
+          <p:cNvPicPr>
+            <a:picLocks noChangeAspect="1"/>
+          </p:cNvPicPr>
+          <p:nvPr/>
+        </p:nvPicPr>
+        <p:blipFill>
+          <a:blip r:embed="rId2"/>
+          <a:stretch>
+            <a:fillRect/>
+          </a:stretch>
+        </p:blipFill>
+        <p:spPr>
+          <a:xfrm>
+            <a:off x="6217920" y="2657346"/>
+            <a:ext cx="5623560" cy="2000507"/>
+          </a:xfrm>
+          <a:prstGeom prst="rect">
+            <a:avLst/>
+          </a:prstGeom>
+        </p:spPr>
+      </p:pic>
+      <p:sp>
+        <p:nvSpPr>
+          <p:cNvPr id="36" name="TextBox 35"/>
           <p:cNvSpPr txBox="1"/>
           <p:nvPr/>
         </p:nvSpPr>
@@ -7646,7 +8034,7 @@
       </p:sp>
       <p:sp>
         <p:nvSpPr>
-          <p:cNvPr id="25" name="TextBox 24"/>
+          <p:cNvPr id="37" name="TextBox 36"/>
           <p:cNvSpPr txBox="1"/>
           <p:nvPr/>
         </p:nvSpPr>
@@ -7688,6 +8076,2396 @@
 </file>
 
 <file path=ppt/slides/slide14.xml><?xml version="1.0" encoding="utf-8"?>
+<p:sld xmlns:a="http://schemas.openxmlformats.org/drawingml/2006/main" xmlns:p="http://schemas.openxmlformats.org/presentationml/2006/main" xmlns:r="http://schemas.openxmlformats.org/officeDocument/2006/relationships">
+  <p:cSld>
+    <p:spTree>
+      <p:nvGrpSpPr>
+        <p:cNvPr id="1" name=""/>
+        <p:cNvGrpSpPr/>
+        <p:nvPr/>
+      </p:nvGrpSpPr>
+      <p:grpSpPr/>
+      <p:sp>
+        <p:nvSpPr>
+          <p:cNvPr id="2" name="Rectangle 1"/>
+          <p:cNvSpPr/>
+          <p:nvPr/>
+        </p:nvSpPr>
+        <p:spPr>
+          <a:xfrm>
+            <a:off x="0" y="0"/>
+            <a:ext cx="12191695" cy="1051560"/>
+          </a:xfrm>
+          <a:prstGeom prst="rect">
+            <a:avLst/>
+          </a:prstGeom>
+          <a:solidFill>
+            <a:srgbClr val="003E7E"/>
+          </a:solidFill>
+          <a:ln>
+            <a:noFill/>
+          </a:ln>
+          <a:effectLst/>
+        </p:spPr>
+        <p:style>
+          <a:lnRef idx="1">
+            <a:schemeClr val="accent1"/>
+          </a:lnRef>
+          <a:fillRef idx="3">
+            <a:schemeClr val="accent1"/>
+          </a:fillRef>
+          <a:effectRef idx="2">
+            <a:schemeClr val="accent1"/>
+          </a:effectRef>
+          <a:fontRef idx="minor">
+            <a:schemeClr val="lt1"/>
+          </a:fontRef>
+        </p:style>
+        <p:txBody>
+          <a:bodyPr rtlCol="0" anchor="ctr"/>
+          <a:lstStyle/>
+          <a:p>
+            <a:pPr algn="ctr"/>
+          </a:p>
+        </p:txBody>
+      </p:sp>
+      <p:sp>
+        <p:nvSpPr>
+          <p:cNvPr id="3" name="Rectangle 2"/>
+          <p:cNvSpPr/>
+          <p:nvPr/>
+        </p:nvSpPr>
+        <p:spPr>
+          <a:xfrm>
+            <a:off x="0" y="1051560"/>
+            <a:ext cx="12191695" cy="38100"/>
+          </a:xfrm>
+          <a:prstGeom prst="rect">
+            <a:avLst/>
+          </a:prstGeom>
+          <a:solidFill>
+            <a:srgbClr val="2E5FA3"/>
+          </a:solidFill>
+          <a:ln>
+            <a:noFill/>
+          </a:ln>
+          <a:effectLst/>
+        </p:spPr>
+        <p:style>
+          <a:lnRef idx="1">
+            <a:schemeClr val="accent1"/>
+          </a:lnRef>
+          <a:fillRef idx="3">
+            <a:schemeClr val="accent1"/>
+          </a:fillRef>
+          <a:effectRef idx="2">
+            <a:schemeClr val="accent1"/>
+          </a:effectRef>
+          <a:fontRef idx="minor">
+            <a:schemeClr val="lt1"/>
+          </a:fontRef>
+        </p:style>
+        <p:txBody>
+          <a:bodyPr rtlCol="0" anchor="ctr"/>
+          <a:lstStyle/>
+          <a:p>
+            <a:pPr algn="ctr"/>
+          </a:p>
+        </p:txBody>
+      </p:sp>
+      <p:sp>
+        <p:nvSpPr>
+          <p:cNvPr id="4" name="TextBox 3"/>
+          <p:cNvSpPr txBox="1"/>
+          <p:nvPr/>
+        </p:nvSpPr>
+        <p:spPr>
+          <a:xfrm>
+            <a:off x="502920" y="109728"/>
+            <a:ext cx="9601200" cy="365760"/>
+          </a:xfrm>
+          <a:prstGeom prst="rect">
+            <a:avLst/>
+          </a:prstGeom>
+          <a:noFill/>
+        </p:spPr>
+        <p:txBody>
+          <a:bodyPr wrap="square" anchor="t">
+            <a:spAutoFit/>
+          </a:bodyPr>
+          <a:lstStyle/>
+          <a:p>
+            <a:pPr algn="l"/>
+            <a:r>
+              <a:rPr sz="1200" b="1" i="0">
+                <a:solidFill>
+                  <a:srgbClr val="AAC8EB"/>
+                </a:solidFill>
+                <a:latin typeface="Calibri"/>
+              </a:rPr>
+              <a:t>LIMITATIONS &amp; FUTURE WORK</a:t>
+            </a:r>
+          </a:p>
+        </p:txBody>
+      </p:sp>
+      <p:sp>
+        <p:nvSpPr>
+          <p:cNvPr id="5" name="TextBox 4"/>
+          <p:cNvSpPr txBox="1"/>
+          <p:nvPr/>
+        </p:nvSpPr>
+        <p:spPr>
+          <a:xfrm>
+            <a:off x="502920" y="365760"/>
+            <a:ext cx="10607040" cy="640080"/>
+          </a:xfrm>
+          <a:prstGeom prst="rect">
+            <a:avLst/>
+          </a:prstGeom>
+          <a:noFill/>
+        </p:spPr>
+        <p:txBody>
+          <a:bodyPr wrap="square" anchor="t">
+            <a:spAutoFit/>
+          </a:bodyPr>
+          <a:lstStyle/>
+          <a:p>
+            <a:pPr algn="l"/>
+            <a:r>
+              <a:rPr sz="2600" b="1" i="0">
+                <a:solidFill>
+                  <a:srgbClr val="FFFFFF"/>
+                </a:solidFill>
+                <a:latin typeface="Calibri"/>
+              </a:rPr>
+              <a:t>What we would do differently</a:t>
+            </a:r>
+          </a:p>
+        </p:txBody>
+      </p:sp>
+      <p:sp>
+        <p:nvSpPr>
+          <p:cNvPr id="6" name="Rectangle 5"/>
+          <p:cNvSpPr/>
+          <p:nvPr/>
+        </p:nvSpPr>
+        <p:spPr>
+          <a:xfrm>
+            <a:off x="10058400" y="274320"/>
+            <a:ext cx="1737360" cy="457200"/>
+          </a:xfrm>
+          <a:prstGeom prst="rect">
+            <a:avLst/>
+          </a:prstGeom>
+          <a:solidFill>
+            <a:srgbClr val="2E5FA3"/>
+          </a:solidFill>
+          <a:ln>
+            <a:noFill/>
+          </a:ln>
+          <a:effectLst/>
+        </p:spPr>
+        <p:style>
+          <a:lnRef idx="1">
+            <a:schemeClr val="accent1"/>
+          </a:lnRef>
+          <a:fillRef idx="3">
+            <a:schemeClr val="accent1"/>
+          </a:fillRef>
+          <a:effectRef idx="2">
+            <a:schemeClr val="accent1"/>
+          </a:effectRef>
+          <a:fontRef idx="minor">
+            <a:schemeClr val="lt1"/>
+          </a:fontRef>
+        </p:style>
+        <p:txBody>
+          <a:bodyPr rtlCol="0" anchor="ctr"/>
+          <a:lstStyle/>
+          <a:p>
+            <a:pPr algn="ctr"/>
+          </a:p>
+        </p:txBody>
+      </p:sp>
+      <p:sp>
+        <p:nvSpPr>
+          <p:cNvPr id="7" name="TextBox 6"/>
+          <p:cNvSpPr txBox="1"/>
+          <p:nvPr/>
+        </p:nvSpPr>
+        <p:spPr>
+          <a:xfrm>
+            <a:off x="10058400" y="274320"/>
+            <a:ext cx="1737360" cy="457200"/>
+          </a:xfrm>
+          <a:prstGeom prst="rect">
+            <a:avLst/>
+          </a:prstGeom>
+          <a:noFill/>
+        </p:spPr>
+        <p:txBody>
+          <a:bodyPr wrap="square" anchor="ctr">
+            <a:spAutoFit/>
+          </a:bodyPr>
+          <a:lstStyle/>
+          <a:p>
+            <a:pPr algn="ctr"/>
+            <a:r>
+              <a:rPr sz="1300" b="1" i="0">
+                <a:solidFill>
+                  <a:srgbClr val="FFFFFF"/>
+                </a:solidFill>
+                <a:latin typeface="Calibri"/>
+              </a:rPr>
+              <a:t>LYAM</a:t>
+            </a:r>
+          </a:p>
+        </p:txBody>
+      </p:sp>
+      <p:sp>
+        <p:nvSpPr>
+          <p:cNvPr id="8" name="Rectangle 7"/>
+          <p:cNvSpPr/>
+          <p:nvPr/>
+        </p:nvSpPr>
+        <p:spPr>
+          <a:xfrm>
+            <a:off x="502920" y="1371600"/>
+            <a:ext cx="502920" cy="1234440"/>
+          </a:xfrm>
+          <a:prstGeom prst="rect">
+            <a:avLst/>
+          </a:prstGeom>
+          <a:solidFill>
+            <a:srgbClr val="B45F1E"/>
+          </a:solidFill>
+          <a:ln>
+            <a:noFill/>
+          </a:ln>
+          <a:effectLst/>
+        </p:spPr>
+        <p:style>
+          <a:lnRef idx="1">
+            <a:schemeClr val="accent1"/>
+          </a:lnRef>
+          <a:fillRef idx="3">
+            <a:schemeClr val="accent1"/>
+          </a:fillRef>
+          <a:effectRef idx="2">
+            <a:schemeClr val="accent1"/>
+          </a:effectRef>
+          <a:fontRef idx="minor">
+            <a:schemeClr val="lt1"/>
+          </a:fontRef>
+        </p:style>
+        <p:txBody>
+          <a:bodyPr rtlCol="0" anchor="ctr"/>
+          <a:lstStyle/>
+          <a:p>
+            <a:pPr algn="ctr"/>
+          </a:p>
+        </p:txBody>
+      </p:sp>
+      <p:sp>
+        <p:nvSpPr>
+          <p:cNvPr id="9" name="TextBox 8"/>
+          <p:cNvSpPr txBox="1"/>
+          <p:nvPr/>
+        </p:nvSpPr>
+        <p:spPr>
+          <a:xfrm>
+            <a:off x="502920" y="1371600"/>
+            <a:ext cx="502920" cy="1234440"/>
+          </a:xfrm>
+          <a:prstGeom prst="rect">
+            <a:avLst/>
+          </a:prstGeom>
+          <a:noFill/>
+        </p:spPr>
+        <p:txBody>
+          <a:bodyPr wrap="square" anchor="ctr">
+            <a:spAutoFit/>
+          </a:bodyPr>
+          <a:lstStyle/>
+          <a:p>
+            <a:pPr algn="ctr"/>
+            <a:r>
+              <a:rPr sz="2000" b="1" i="0">
+                <a:solidFill>
+                  <a:srgbClr val="FFFFFF"/>
+                </a:solidFill>
+                <a:latin typeface="Calibri"/>
+              </a:rPr>
+              <a:t>1</a:t>
+            </a:r>
+          </a:p>
+        </p:txBody>
+      </p:sp>
+      <p:sp>
+        <p:nvSpPr>
+          <p:cNvPr id="10" name="Rectangle 9"/>
+          <p:cNvSpPr/>
+          <p:nvPr/>
+        </p:nvSpPr>
+        <p:spPr>
+          <a:xfrm>
+            <a:off x="1097280" y="1371600"/>
+            <a:ext cx="4892040" cy="1234440"/>
+          </a:xfrm>
+          <a:prstGeom prst="rect">
+            <a:avLst/>
+          </a:prstGeom>
+          <a:solidFill>
+            <a:srgbClr val="EEF3F9"/>
+          </a:solidFill>
+          <a:ln>
+            <a:noFill/>
+          </a:ln>
+          <a:effectLst/>
+        </p:spPr>
+        <p:style>
+          <a:lnRef idx="1">
+            <a:schemeClr val="accent1"/>
+          </a:lnRef>
+          <a:fillRef idx="3">
+            <a:schemeClr val="accent1"/>
+          </a:fillRef>
+          <a:effectRef idx="2">
+            <a:schemeClr val="accent1"/>
+          </a:effectRef>
+          <a:fontRef idx="minor">
+            <a:schemeClr val="lt1"/>
+          </a:fontRef>
+        </p:style>
+        <p:txBody>
+          <a:bodyPr rtlCol="0" anchor="ctr"/>
+          <a:lstStyle/>
+          <a:p>
+            <a:pPr algn="ctr"/>
+          </a:p>
+        </p:txBody>
+      </p:sp>
+      <p:sp>
+        <p:nvSpPr>
+          <p:cNvPr id="11" name="TextBox 10"/>
+          <p:cNvSpPr txBox="1"/>
+          <p:nvPr/>
+        </p:nvSpPr>
+        <p:spPr>
+          <a:xfrm>
+            <a:off x="1188720" y="1444752"/>
+            <a:ext cx="4754880" cy="1097280"/>
+          </a:xfrm>
+          <a:prstGeom prst="rect">
+            <a:avLst/>
+          </a:prstGeom>
+          <a:noFill/>
+        </p:spPr>
+        <p:txBody>
+          <a:bodyPr wrap="square" anchor="t">
+            <a:spAutoFit/>
+          </a:bodyPr>
+          <a:lstStyle/>
+          <a:p>
+            <a:pPr algn="l"/>
+            <a:r>
+              <a:rPr sz="1450" b="1" i="0">
+                <a:solidFill>
+                  <a:srgbClr val="003E7E"/>
+                </a:solidFill>
+                <a:latin typeface="Calibri"/>
+              </a:rPr>
+              <a:t>ERA5 = upper bound</a:t>
+            </a:r>
+          </a:p>
+          <a:p>
+            <a:pPr algn="l">
+              <a:spcBef>
+                <a:spcPts val="200"/>
+              </a:spcBef>
+            </a:pPr>
+            <a:r>
+              <a:rPr sz="1200" b="0" i="0">
+                <a:solidFill>
+                  <a:srgbClr val="212529"/>
+                </a:solidFill>
+                <a:latin typeface="Calibri"/>
+              </a:rPr>
+              <a:t>Reanalysis gives perfect hindsight weather — production would use NWP forecasts with 10–30% error. Our result is a ceiling on weather value.</a:t>
+            </a:r>
+          </a:p>
+        </p:txBody>
+      </p:sp>
+      <p:sp>
+        <p:nvSpPr>
+          <p:cNvPr id="12" name="Rectangle 11"/>
+          <p:cNvSpPr/>
+          <p:nvPr/>
+        </p:nvSpPr>
+        <p:spPr>
+          <a:xfrm>
+            <a:off x="6263640" y="1371600"/>
+            <a:ext cx="502920" cy="1234440"/>
+          </a:xfrm>
+          <a:prstGeom prst="rect">
+            <a:avLst/>
+          </a:prstGeom>
+          <a:solidFill>
+            <a:srgbClr val="B45F1E"/>
+          </a:solidFill>
+          <a:ln>
+            <a:noFill/>
+          </a:ln>
+          <a:effectLst/>
+        </p:spPr>
+        <p:style>
+          <a:lnRef idx="1">
+            <a:schemeClr val="accent1"/>
+          </a:lnRef>
+          <a:fillRef idx="3">
+            <a:schemeClr val="accent1"/>
+          </a:fillRef>
+          <a:effectRef idx="2">
+            <a:schemeClr val="accent1"/>
+          </a:effectRef>
+          <a:fontRef idx="minor">
+            <a:schemeClr val="lt1"/>
+          </a:fontRef>
+        </p:style>
+        <p:txBody>
+          <a:bodyPr rtlCol="0" anchor="ctr"/>
+          <a:lstStyle/>
+          <a:p>
+            <a:pPr algn="ctr"/>
+          </a:p>
+        </p:txBody>
+      </p:sp>
+      <p:sp>
+        <p:nvSpPr>
+          <p:cNvPr id="13" name="TextBox 12"/>
+          <p:cNvSpPr txBox="1"/>
+          <p:nvPr/>
+        </p:nvSpPr>
+        <p:spPr>
+          <a:xfrm>
+            <a:off x="6263640" y="1371600"/>
+            <a:ext cx="502920" cy="1234440"/>
+          </a:xfrm>
+          <a:prstGeom prst="rect">
+            <a:avLst/>
+          </a:prstGeom>
+          <a:noFill/>
+        </p:spPr>
+        <p:txBody>
+          <a:bodyPr wrap="square" anchor="ctr">
+            <a:spAutoFit/>
+          </a:bodyPr>
+          <a:lstStyle/>
+          <a:p>
+            <a:pPr algn="ctr"/>
+            <a:r>
+              <a:rPr sz="2000" b="1" i="0">
+                <a:solidFill>
+                  <a:srgbClr val="FFFFFF"/>
+                </a:solidFill>
+                <a:latin typeface="Calibri"/>
+              </a:rPr>
+              <a:t>2</a:t>
+            </a:r>
+          </a:p>
+        </p:txBody>
+      </p:sp>
+      <p:sp>
+        <p:nvSpPr>
+          <p:cNvPr id="14" name="Rectangle 13"/>
+          <p:cNvSpPr/>
+          <p:nvPr/>
+        </p:nvSpPr>
+        <p:spPr>
+          <a:xfrm>
+            <a:off x="6858000" y="1371600"/>
+            <a:ext cx="4892040" cy="1234440"/>
+          </a:xfrm>
+          <a:prstGeom prst="rect">
+            <a:avLst/>
+          </a:prstGeom>
+          <a:solidFill>
+            <a:srgbClr val="EEF3F9"/>
+          </a:solidFill>
+          <a:ln>
+            <a:noFill/>
+          </a:ln>
+          <a:effectLst/>
+        </p:spPr>
+        <p:style>
+          <a:lnRef idx="1">
+            <a:schemeClr val="accent1"/>
+          </a:lnRef>
+          <a:fillRef idx="3">
+            <a:schemeClr val="accent1"/>
+          </a:fillRef>
+          <a:effectRef idx="2">
+            <a:schemeClr val="accent1"/>
+          </a:effectRef>
+          <a:fontRef idx="minor">
+            <a:schemeClr val="lt1"/>
+          </a:fontRef>
+        </p:style>
+        <p:txBody>
+          <a:bodyPr rtlCol="0" anchor="ctr"/>
+          <a:lstStyle/>
+          <a:p>
+            <a:pPr algn="ctr"/>
+          </a:p>
+        </p:txBody>
+      </p:sp>
+      <p:sp>
+        <p:nvSpPr>
+          <p:cNvPr id="15" name="TextBox 14"/>
+          <p:cNvSpPr txBox="1"/>
+          <p:nvPr/>
+        </p:nvSpPr>
+        <p:spPr>
+          <a:xfrm>
+            <a:off x="6949440" y="1444752"/>
+            <a:ext cx="4754880" cy="1097280"/>
+          </a:xfrm>
+          <a:prstGeom prst="rect">
+            <a:avLst/>
+          </a:prstGeom>
+          <a:noFill/>
+        </p:spPr>
+        <p:txBody>
+          <a:bodyPr wrap="square" anchor="t">
+            <a:spAutoFit/>
+          </a:bodyPr>
+          <a:lstStyle/>
+          <a:p>
+            <a:pPr algn="l"/>
+            <a:r>
+              <a:rPr sz="1450" b="1" i="0">
+                <a:solidFill>
+                  <a:srgbClr val="003E7E"/>
+                </a:solidFill>
+                <a:latin typeface="Calibri"/>
+              </a:rPr>
+              <a:t>No walk-forward retraining</a:t>
+            </a:r>
+          </a:p>
+          <a:p>
+            <a:pPr algn="l">
+              <a:spcBef>
+                <a:spcPts val="200"/>
+              </a:spcBef>
+            </a:pPr>
+            <a:r>
+              <a:rPr sz="1200" b="0" i="0">
+                <a:solidFill>
+                  <a:srgbClr val="212529"/>
+                </a:solidFill>
+                <a:latin typeface="Calibri"/>
+              </a:rPr>
+              <a:t>Single batch training; monthly retraining on an expanding window would better reflect real trading conditions.</a:t>
+            </a:r>
+          </a:p>
+        </p:txBody>
+      </p:sp>
+      <p:sp>
+        <p:nvSpPr>
+          <p:cNvPr id="16" name="Rectangle 15"/>
+          <p:cNvSpPr/>
+          <p:nvPr/>
+        </p:nvSpPr>
+        <p:spPr>
+          <a:xfrm>
+            <a:off x="502920" y="2834640"/>
+            <a:ext cx="502920" cy="1234440"/>
+          </a:xfrm>
+          <a:prstGeom prst="rect">
+            <a:avLst/>
+          </a:prstGeom>
+          <a:solidFill>
+            <a:srgbClr val="B45F1E"/>
+          </a:solidFill>
+          <a:ln>
+            <a:noFill/>
+          </a:ln>
+          <a:effectLst/>
+        </p:spPr>
+        <p:style>
+          <a:lnRef idx="1">
+            <a:schemeClr val="accent1"/>
+          </a:lnRef>
+          <a:fillRef idx="3">
+            <a:schemeClr val="accent1"/>
+          </a:fillRef>
+          <a:effectRef idx="2">
+            <a:schemeClr val="accent1"/>
+          </a:effectRef>
+          <a:fontRef idx="minor">
+            <a:schemeClr val="lt1"/>
+          </a:fontRef>
+        </p:style>
+        <p:txBody>
+          <a:bodyPr rtlCol="0" anchor="ctr"/>
+          <a:lstStyle/>
+          <a:p>
+            <a:pPr algn="ctr"/>
+          </a:p>
+        </p:txBody>
+      </p:sp>
+      <p:sp>
+        <p:nvSpPr>
+          <p:cNvPr id="17" name="TextBox 16"/>
+          <p:cNvSpPr txBox="1"/>
+          <p:nvPr/>
+        </p:nvSpPr>
+        <p:spPr>
+          <a:xfrm>
+            <a:off x="502920" y="2834640"/>
+            <a:ext cx="502920" cy="1234440"/>
+          </a:xfrm>
+          <a:prstGeom prst="rect">
+            <a:avLst/>
+          </a:prstGeom>
+          <a:noFill/>
+        </p:spPr>
+        <p:txBody>
+          <a:bodyPr wrap="square" anchor="ctr">
+            <a:spAutoFit/>
+          </a:bodyPr>
+          <a:lstStyle/>
+          <a:p>
+            <a:pPr algn="ctr"/>
+            <a:r>
+              <a:rPr sz="2000" b="1" i="0">
+                <a:solidFill>
+                  <a:srgbClr val="FFFFFF"/>
+                </a:solidFill>
+                <a:latin typeface="Calibri"/>
+              </a:rPr>
+              <a:t>3</a:t>
+            </a:r>
+          </a:p>
+        </p:txBody>
+      </p:sp>
+      <p:sp>
+        <p:nvSpPr>
+          <p:cNvPr id="18" name="Rectangle 17"/>
+          <p:cNvSpPr/>
+          <p:nvPr/>
+        </p:nvSpPr>
+        <p:spPr>
+          <a:xfrm>
+            <a:off x="1097280" y="2834640"/>
+            <a:ext cx="4892040" cy="1234440"/>
+          </a:xfrm>
+          <a:prstGeom prst="rect">
+            <a:avLst/>
+          </a:prstGeom>
+          <a:solidFill>
+            <a:srgbClr val="EEF3F9"/>
+          </a:solidFill>
+          <a:ln>
+            <a:noFill/>
+          </a:ln>
+          <a:effectLst/>
+        </p:spPr>
+        <p:style>
+          <a:lnRef idx="1">
+            <a:schemeClr val="accent1"/>
+          </a:lnRef>
+          <a:fillRef idx="3">
+            <a:schemeClr val="accent1"/>
+          </a:fillRef>
+          <a:effectRef idx="2">
+            <a:schemeClr val="accent1"/>
+          </a:effectRef>
+          <a:fontRef idx="minor">
+            <a:schemeClr val="lt1"/>
+          </a:fontRef>
+        </p:style>
+        <p:txBody>
+          <a:bodyPr rtlCol="0" anchor="ctr"/>
+          <a:lstStyle/>
+          <a:p>
+            <a:pPr algn="ctr"/>
+          </a:p>
+        </p:txBody>
+      </p:sp>
+      <p:sp>
+        <p:nvSpPr>
+          <p:cNvPr id="19" name="TextBox 18"/>
+          <p:cNvSpPr txBox="1"/>
+          <p:nvPr/>
+        </p:nvSpPr>
+        <p:spPr>
+          <a:xfrm>
+            <a:off x="1188720" y="2907792"/>
+            <a:ext cx="4754880" cy="1097280"/>
+          </a:xfrm>
+          <a:prstGeom prst="rect">
+            <a:avLst/>
+          </a:prstGeom>
+          <a:noFill/>
+        </p:spPr>
+        <p:txBody>
+          <a:bodyPr wrap="square" anchor="t">
+            <a:spAutoFit/>
+          </a:bodyPr>
+          <a:lstStyle/>
+          <a:p>
+            <a:pPr algn="l"/>
+            <a:r>
+              <a:rPr sz="1450" b="1" i="0">
+                <a:solidFill>
+                  <a:srgbClr val="003E7E"/>
+                </a:solidFill>
+                <a:latin typeface="Calibri"/>
+              </a:rPr>
+              <a:t>Carbon prices (EUA) excluded</a:t>
+            </a:r>
+          </a:p>
+          <a:p>
+            <a:pPr algn="l">
+              <a:spcBef>
+                <a:spcPts val="200"/>
+              </a:spcBef>
+            </a:pPr>
+            <a:r>
+              <a:rPr sz="1200" b="0" i="0">
+                <a:solidFill>
+                  <a:srgbClr val="212529"/>
+                </a:solidFill>
+                <a:latin typeface="Calibri"/>
+              </a:rPr>
+              <a:t>EUA correlates with TTF/coal — partly absorbed — but should be tested explicitly as an additional feature.</a:t>
+            </a:r>
+          </a:p>
+        </p:txBody>
+      </p:sp>
+      <p:sp>
+        <p:nvSpPr>
+          <p:cNvPr id="20" name="Rectangle 19"/>
+          <p:cNvSpPr/>
+          <p:nvPr/>
+        </p:nvSpPr>
+        <p:spPr>
+          <a:xfrm>
+            <a:off x="6263640" y="2834640"/>
+            <a:ext cx="502920" cy="1234440"/>
+          </a:xfrm>
+          <a:prstGeom prst="rect">
+            <a:avLst/>
+          </a:prstGeom>
+          <a:solidFill>
+            <a:srgbClr val="B45F1E"/>
+          </a:solidFill>
+          <a:ln>
+            <a:noFill/>
+          </a:ln>
+          <a:effectLst/>
+        </p:spPr>
+        <p:style>
+          <a:lnRef idx="1">
+            <a:schemeClr val="accent1"/>
+          </a:lnRef>
+          <a:fillRef idx="3">
+            <a:schemeClr val="accent1"/>
+          </a:fillRef>
+          <a:effectRef idx="2">
+            <a:schemeClr val="accent1"/>
+          </a:effectRef>
+          <a:fontRef idx="minor">
+            <a:schemeClr val="lt1"/>
+          </a:fontRef>
+        </p:style>
+        <p:txBody>
+          <a:bodyPr rtlCol="0" anchor="ctr"/>
+          <a:lstStyle/>
+          <a:p>
+            <a:pPr algn="ctr"/>
+          </a:p>
+        </p:txBody>
+      </p:sp>
+      <p:sp>
+        <p:nvSpPr>
+          <p:cNvPr id="21" name="TextBox 20"/>
+          <p:cNvSpPr txBox="1"/>
+          <p:nvPr/>
+        </p:nvSpPr>
+        <p:spPr>
+          <a:xfrm>
+            <a:off x="6263640" y="2834640"/>
+            <a:ext cx="502920" cy="1234440"/>
+          </a:xfrm>
+          <a:prstGeom prst="rect">
+            <a:avLst/>
+          </a:prstGeom>
+          <a:noFill/>
+        </p:spPr>
+        <p:txBody>
+          <a:bodyPr wrap="square" anchor="ctr">
+            <a:spAutoFit/>
+          </a:bodyPr>
+          <a:lstStyle/>
+          <a:p>
+            <a:pPr algn="ctr"/>
+            <a:r>
+              <a:rPr sz="2000" b="1" i="0">
+                <a:solidFill>
+                  <a:srgbClr val="FFFFFF"/>
+                </a:solidFill>
+                <a:latin typeface="Calibri"/>
+              </a:rPr>
+              <a:t>4</a:t>
+            </a:r>
+          </a:p>
+        </p:txBody>
+      </p:sp>
+      <p:sp>
+        <p:nvSpPr>
+          <p:cNvPr id="22" name="Rectangle 21"/>
+          <p:cNvSpPr/>
+          <p:nvPr/>
+        </p:nvSpPr>
+        <p:spPr>
+          <a:xfrm>
+            <a:off x="6858000" y="2834640"/>
+            <a:ext cx="4892040" cy="1234440"/>
+          </a:xfrm>
+          <a:prstGeom prst="rect">
+            <a:avLst/>
+          </a:prstGeom>
+          <a:solidFill>
+            <a:srgbClr val="EEF3F9"/>
+          </a:solidFill>
+          <a:ln>
+            <a:noFill/>
+          </a:ln>
+          <a:effectLst/>
+        </p:spPr>
+        <p:style>
+          <a:lnRef idx="1">
+            <a:schemeClr val="accent1"/>
+          </a:lnRef>
+          <a:fillRef idx="3">
+            <a:schemeClr val="accent1"/>
+          </a:fillRef>
+          <a:effectRef idx="2">
+            <a:schemeClr val="accent1"/>
+          </a:effectRef>
+          <a:fontRef idx="minor">
+            <a:schemeClr val="lt1"/>
+          </a:fontRef>
+        </p:style>
+        <p:txBody>
+          <a:bodyPr rtlCol="0" anchor="ctr"/>
+          <a:lstStyle/>
+          <a:p>
+            <a:pPr algn="ctr"/>
+          </a:p>
+        </p:txBody>
+      </p:sp>
+      <p:sp>
+        <p:nvSpPr>
+          <p:cNvPr id="23" name="TextBox 22"/>
+          <p:cNvSpPr txBox="1"/>
+          <p:nvPr/>
+        </p:nvSpPr>
+        <p:spPr>
+          <a:xfrm>
+            <a:off x="6949440" y="2907792"/>
+            <a:ext cx="4754880" cy="1097280"/>
+          </a:xfrm>
+          <a:prstGeom prst="rect">
+            <a:avLst/>
+          </a:prstGeom>
+          <a:noFill/>
+        </p:spPr>
+        <p:txBody>
+          <a:bodyPr wrap="square" anchor="t">
+            <a:spAutoFit/>
+          </a:bodyPr>
+          <a:lstStyle/>
+          <a:p>
+            <a:pPr algn="l"/>
+            <a:r>
+              <a:rPr sz="1450" b="1" i="0">
+                <a:solidFill>
+                  <a:srgbClr val="003E7E"/>
+                </a:solidFill>
+                <a:latin typeface="Calibri"/>
+              </a:rPr>
+              <a:t>XGBoost not fully tuned</a:t>
+            </a:r>
+          </a:p>
+          <a:p>
+            <a:pPr algn="l">
+              <a:spcBef>
+                <a:spcPts val="200"/>
+              </a:spcBef>
+            </a:pPr>
+            <a:r>
+              <a:rPr sz="1200" b="0" i="0">
+                <a:solidFill>
+                  <a:srgbClr val="212529"/>
+                </a:solidFill>
+                <a:latin typeface="Calibri"/>
+              </a:rPr>
+              <a:t>Default hyperparameters; Bayesian optimisation could close or reverse the RF vs XGBoost gap.</a:t>
+            </a:r>
+          </a:p>
+        </p:txBody>
+      </p:sp>
+      <p:sp>
+        <p:nvSpPr>
+          <p:cNvPr id="24" name="Rectangle 23"/>
+          <p:cNvSpPr/>
+          <p:nvPr/>
+        </p:nvSpPr>
+        <p:spPr>
+          <a:xfrm>
+            <a:off x="502920" y="4297680"/>
+            <a:ext cx="502920" cy="1234440"/>
+          </a:xfrm>
+          <a:prstGeom prst="rect">
+            <a:avLst/>
+          </a:prstGeom>
+          <a:solidFill>
+            <a:srgbClr val="B45F1E"/>
+          </a:solidFill>
+          <a:ln>
+            <a:noFill/>
+          </a:ln>
+          <a:effectLst/>
+        </p:spPr>
+        <p:style>
+          <a:lnRef idx="1">
+            <a:schemeClr val="accent1"/>
+          </a:lnRef>
+          <a:fillRef idx="3">
+            <a:schemeClr val="accent1"/>
+          </a:fillRef>
+          <a:effectRef idx="2">
+            <a:schemeClr val="accent1"/>
+          </a:effectRef>
+          <a:fontRef idx="minor">
+            <a:schemeClr val="lt1"/>
+          </a:fontRef>
+        </p:style>
+        <p:txBody>
+          <a:bodyPr rtlCol="0" anchor="ctr"/>
+          <a:lstStyle/>
+          <a:p>
+            <a:pPr algn="ctr"/>
+          </a:p>
+        </p:txBody>
+      </p:sp>
+      <p:sp>
+        <p:nvSpPr>
+          <p:cNvPr id="25" name="TextBox 24"/>
+          <p:cNvSpPr txBox="1"/>
+          <p:nvPr/>
+        </p:nvSpPr>
+        <p:spPr>
+          <a:xfrm>
+            <a:off x="502920" y="4297680"/>
+            <a:ext cx="502920" cy="1234440"/>
+          </a:xfrm>
+          <a:prstGeom prst="rect">
+            <a:avLst/>
+          </a:prstGeom>
+          <a:noFill/>
+        </p:spPr>
+        <p:txBody>
+          <a:bodyPr wrap="square" anchor="ctr">
+            <a:spAutoFit/>
+          </a:bodyPr>
+          <a:lstStyle/>
+          <a:p>
+            <a:pPr algn="ctr"/>
+            <a:r>
+              <a:rPr sz="2000" b="1" i="0">
+                <a:solidFill>
+                  <a:srgbClr val="FFFFFF"/>
+                </a:solidFill>
+                <a:latin typeface="Calibri"/>
+              </a:rPr>
+              <a:t>5</a:t>
+            </a:r>
+          </a:p>
+        </p:txBody>
+      </p:sp>
+      <p:sp>
+        <p:nvSpPr>
+          <p:cNvPr id="26" name="Rectangle 25"/>
+          <p:cNvSpPr/>
+          <p:nvPr/>
+        </p:nvSpPr>
+        <p:spPr>
+          <a:xfrm>
+            <a:off x="1097280" y="4297680"/>
+            <a:ext cx="4892040" cy="1234440"/>
+          </a:xfrm>
+          <a:prstGeom prst="rect">
+            <a:avLst/>
+          </a:prstGeom>
+          <a:solidFill>
+            <a:srgbClr val="EEF3F9"/>
+          </a:solidFill>
+          <a:ln>
+            <a:noFill/>
+          </a:ln>
+          <a:effectLst/>
+        </p:spPr>
+        <p:style>
+          <a:lnRef idx="1">
+            <a:schemeClr val="accent1"/>
+          </a:lnRef>
+          <a:fillRef idx="3">
+            <a:schemeClr val="accent1"/>
+          </a:fillRef>
+          <a:effectRef idx="2">
+            <a:schemeClr val="accent1"/>
+          </a:effectRef>
+          <a:fontRef idx="minor">
+            <a:schemeClr val="lt1"/>
+          </a:fontRef>
+        </p:style>
+        <p:txBody>
+          <a:bodyPr rtlCol="0" anchor="ctr"/>
+          <a:lstStyle/>
+          <a:p>
+            <a:pPr algn="ctr"/>
+          </a:p>
+        </p:txBody>
+      </p:sp>
+      <p:sp>
+        <p:nvSpPr>
+          <p:cNvPr id="27" name="TextBox 26"/>
+          <p:cNvSpPr txBox="1"/>
+          <p:nvPr/>
+        </p:nvSpPr>
+        <p:spPr>
+          <a:xfrm>
+            <a:off x="1188720" y="4370832"/>
+            <a:ext cx="4754880" cy="1097280"/>
+          </a:xfrm>
+          <a:prstGeom prst="rect">
+            <a:avLst/>
+          </a:prstGeom>
+          <a:noFill/>
+        </p:spPr>
+        <p:txBody>
+          <a:bodyPr wrap="square" anchor="t">
+            <a:spAutoFit/>
+          </a:bodyPr>
+          <a:lstStyle/>
+          <a:p>
+            <a:pPr algn="l"/>
+            <a:r>
+              <a:rPr sz="1450" b="1" i="0">
+                <a:solidFill>
+                  <a:srgbClr val="003E7E"/>
+                </a:solidFill>
+                <a:latin typeface="Calibri"/>
+              </a:rPr>
+              <a:t>France only</a:t>
+            </a:r>
+          </a:p>
+          <a:p>
+            <a:pPr algn="l">
+              <a:spcBef>
+                <a:spcPts val="200"/>
+              </a:spcBef>
+            </a:pPr>
+            <a:r>
+              <a:rPr sz="1200" b="0" i="0">
+                <a:solidFill>
+                  <a:srgbClr val="212529"/>
+                </a:solidFill>
+                <a:latin typeface="Calibri"/>
+              </a:rPr>
+              <a:t>The redundancy mechanism is specific to France's nuclear-dominant, high-thermosensitivity structure. Germany, Spain or UK may differ substantially.</a:t>
+            </a:r>
+          </a:p>
+        </p:txBody>
+      </p:sp>
+      <p:sp>
+        <p:nvSpPr>
+          <p:cNvPr id="28" name="Rectangle 27"/>
+          <p:cNvSpPr/>
+          <p:nvPr/>
+        </p:nvSpPr>
+        <p:spPr>
+          <a:xfrm>
+            <a:off x="6263640" y="4297680"/>
+            <a:ext cx="502920" cy="1234440"/>
+          </a:xfrm>
+          <a:prstGeom prst="rect">
+            <a:avLst/>
+          </a:prstGeom>
+          <a:solidFill>
+            <a:srgbClr val="B45F1E"/>
+          </a:solidFill>
+          <a:ln>
+            <a:noFill/>
+          </a:ln>
+          <a:effectLst/>
+        </p:spPr>
+        <p:style>
+          <a:lnRef idx="1">
+            <a:schemeClr val="accent1"/>
+          </a:lnRef>
+          <a:fillRef idx="3">
+            <a:schemeClr val="accent1"/>
+          </a:fillRef>
+          <a:effectRef idx="2">
+            <a:schemeClr val="accent1"/>
+          </a:effectRef>
+          <a:fontRef idx="minor">
+            <a:schemeClr val="lt1"/>
+          </a:fontRef>
+        </p:style>
+        <p:txBody>
+          <a:bodyPr rtlCol="0" anchor="ctr"/>
+          <a:lstStyle/>
+          <a:p>
+            <a:pPr algn="ctr"/>
+          </a:p>
+        </p:txBody>
+      </p:sp>
+      <p:sp>
+        <p:nvSpPr>
+          <p:cNvPr id="29" name="TextBox 28"/>
+          <p:cNvSpPr txBox="1"/>
+          <p:nvPr/>
+        </p:nvSpPr>
+        <p:spPr>
+          <a:xfrm>
+            <a:off x="6263640" y="4297680"/>
+            <a:ext cx="502920" cy="1234440"/>
+          </a:xfrm>
+          <a:prstGeom prst="rect">
+            <a:avLst/>
+          </a:prstGeom>
+          <a:noFill/>
+        </p:spPr>
+        <p:txBody>
+          <a:bodyPr wrap="square" anchor="ctr">
+            <a:spAutoFit/>
+          </a:bodyPr>
+          <a:lstStyle/>
+          <a:p>
+            <a:pPr algn="ctr"/>
+            <a:r>
+              <a:rPr sz="2000" b="1" i="0">
+                <a:solidFill>
+                  <a:srgbClr val="FFFFFF"/>
+                </a:solidFill>
+                <a:latin typeface="Calibri"/>
+              </a:rPr>
+              <a:t>6</a:t>
+            </a:r>
+          </a:p>
+        </p:txBody>
+      </p:sp>
+      <p:sp>
+        <p:nvSpPr>
+          <p:cNvPr id="30" name="Rectangle 29"/>
+          <p:cNvSpPr/>
+          <p:nvPr/>
+        </p:nvSpPr>
+        <p:spPr>
+          <a:xfrm>
+            <a:off x="6858000" y="4297680"/>
+            <a:ext cx="4892040" cy="1234440"/>
+          </a:xfrm>
+          <a:prstGeom prst="rect">
+            <a:avLst/>
+          </a:prstGeom>
+          <a:solidFill>
+            <a:srgbClr val="EEF3F9"/>
+          </a:solidFill>
+          <a:ln>
+            <a:noFill/>
+          </a:ln>
+          <a:effectLst/>
+        </p:spPr>
+        <p:style>
+          <a:lnRef idx="1">
+            <a:schemeClr val="accent1"/>
+          </a:lnRef>
+          <a:fillRef idx="3">
+            <a:schemeClr val="accent1"/>
+          </a:fillRef>
+          <a:effectRef idx="2">
+            <a:schemeClr val="accent1"/>
+          </a:effectRef>
+          <a:fontRef idx="minor">
+            <a:schemeClr val="lt1"/>
+          </a:fontRef>
+        </p:style>
+        <p:txBody>
+          <a:bodyPr rtlCol="0" anchor="ctr"/>
+          <a:lstStyle/>
+          <a:p>
+            <a:pPr algn="ctr"/>
+          </a:p>
+        </p:txBody>
+      </p:sp>
+      <p:sp>
+        <p:nvSpPr>
+          <p:cNvPr id="31" name="TextBox 30"/>
+          <p:cNvSpPr txBox="1"/>
+          <p:nvPr/>
+        </p:nvSpPr>
+        <p:spPr>
+          <a:xfrm>
+            <a:off x="6949440" y="4370832"/>
+            <a:ext cx="4754880" cy="1097280"/>
+          </a:xfrm>
+          <a:prstGeom prst="rect">
+            <a:avLst/>
+          </a:prstGeom>
+          <a:noFill/>
+        </p:spPr>
+        <p:txBody>
+          <a:bodyPr wrap="square" anchor="t">
+            <a:spAutoFit/>
+          </a:bodyPr>
+          <a:lstStyle/>
+          <a:p>
+            <a:pPr algn="l"/>
+            <a:r>
+              <a:rPr sz="1450" b="1" i="0">
+                <a:solidFill>
+                  <a:srgbClr val="003E7E"/>
+                </a:solidFill>
+                <a:latin typeface="Calibri"/>
+              </a:rPr>
+              <a:t>No market impact</a:t>
+            </a:r>
+          </a:p>
+          <a:p>
+            <a:pPr algn="l">
+              <a:spcBef>
+                <a:spcPts val="200"/>
+              </a:spcBef>
+            </a:pPr>
+            <a:r>
+              <a:rPr sz="1200" b="0" i="0">
+                <a:solidFill>
+                  <a:srgbClr val="212529"/>
+                </a:solidFill>
+                <a:latin typeface="Calibri"/>
+              </a:rPr>
+              <a:t>Transaction costs modelled as flat fee; large positions (&gt;10 MW) would face liquidity constraints not captured here.</a:t>
+            </a:r>
+          </a:p>
+        </p:txBody>
+      </p:sp>
+      <p:sp>
+        <p:nvSpPr>
+          <p:cNvPr id="32" name="TextBox 31"/>
+          <p:cNvSpPr txBox="1"/>
+          <p:nvPr/>
+        </p:nvSpPr>
+        <p:spPr>
+          <a:xfrm>
+            <a:off x="457200" y="6446520"/>
+            <a:ext cx="7315200" cy="320040"/>
+          </a:xfrm>
+          <a:prstGeom prst="rect">
+            <a:avLst/>
+          </a:prstGeom>
+          <a:noFill/>
+        </p:spPr>
+        <p:txBody>
+          <a:bodyPr wrap="square" anchor="t">
+            <a:spAutoFit/>
+          </a:bodyPr>
+          <a:lstStyle/>
+          <a:p>
+            <a:pPr algn="l"/>
+            <a:r>
+              <a:rPr sz="900" b="0" i="0">
+                <a:solidFill>
+                  <a:srgbClr val="6E6E6E"/>
+                </a:solidFill>
+                <a:latin typeface="Calibri"/>
+              </a:rPr>
+              <a:t>Weather in French Day-Ahead Electricity Price Forecasting</a:t>
+            </a:r>
+          </a:p>
+        </p:txBody>
+      </p:sp>
+      <p:sp>
+        <p:nvSpPr>
+          <p:cNvPr id="33" name="TextBox 32"/>
+          <p:cNvSpPr txBox="1"/>
+          <p:nvPr/>
+        </p:nvSpPr>
+        <p:spPr>
+          <a:xfrm>
+            <a:off x="10972800" y="6446520"/>
+            <a:ext cx="822960" cy="320040"/>
+          </a:xfrm>
+          <a:prstGeom prst="rect">
+            <a:avLst/>
+          </a:prstGeom>
+          <a:noFill/>
+        </p:spPr>
+        <p:txBody>
+          <a:bodyPr wrap="square" anchor="t">
+            <a:spAutoFit/>
+          </a:bodyPr>
+          <a:lstStyle/>
+          <a:p>
+            <a:pPr algn="r"/>
+            <a:r>
+              <a:rPr sz="1100" b="1" i="0">
+                <a:solidFill>
+                  <a:srgbClr val="003E7E"/>
+                </a:solidFill>
+                <a:latin typeface="Calibri"/>
+              </a:rPr>
+              <a:t>14</a:t>
+            </a:r>
+          </a:p>
+        </p:txBody>
+      </p:sp>
+    </p:spTree>
+  </p:cSld>
+  <p:clrMapOvr>
+    <a:masterClrMapping/>
+  </p:clrMapOvr>
+</p:sld>
+</file>
+
+<file path=ppt/slides/slide15.xml><?xml version="1.0" encoding="utf-8"?>
+<p:sld xmlns:a="http://schemas.openxmlformats.org/drawingml/2006/main" xmlns:p="http://schemas.openxmlformats.org/presentationml/2006/main" xmlns:r="http://schemas.openxmlformats.org/officeDocument/2006/relationships">
+  <p:cSld>
+    <p:spTree>
+      <p:nvGrpSpPr>
+        <p:cNvPr id="1" name=""/>
+        <p:cNvGrpSpPr/>
+        <p:nvPr/>
+      </p:nvGrpSpPr>
+      <p:grpSpPr/>
+      <p:sp>
+        <p:nvSpPr>
+          <p:cNvPr id="2" name="Rectangle 1"/>
+          <p:cNvSpPr/>
+          <p:nvPr/>
+        </p:nvSpPr>
+        <p:spPr>
+          <a:xfrm>
+            <a:off x="0" y="0"/>
+            <a:ext cx="12191695" cy="1051560"/>
+          </a:xfrm>
+          <a:prstGeom prst="rect">
+            <a:avLst/>
+          </a:prstGeom>
+          <a:solidFill>
+            <a:srgbClr val="003E7E"/>
+          </a:solidFill>
+          <a:ln>
+            <a:noFill/>
+          </a:ln>
+          <a:effectLst/>
+        </p:spPr>
+        <p:style>
+          <a:lnRef idx="1">
+            <a:schemeClr val="accent1"/>
+          </a:lnRef>
+          <a:fillRef idx="3">
+            <a:schemeClr val="accent1"/>
+          </a:fillRef>
+          <a:effectRef idx="2">
+            <a:schemeClr val="accent1"/>
+          </a:effectRef>
+          <a:fontRef idx="minor">
+            <a:schemeClr val="lt1"/>
+          </a:fontRef>
+        </p:style>
+        <p:txBody>
+          <a:bodyPr rtlCol="0" anchor="ctr"/>
+          <a:lstStyle/>
+          <a:p>
+            <a:pPr algn="ctr"/>
+          </a:p>
+        </p:txBody>
+      </p:sp>
+      <p:sp>
+        <p:nvSpPr>
+          <p:cNvPr id="3" name="Rectangle 2"/>
+          <p:cNvSpPr/>
+          <p:nvPr/>
+        </p:nvSpPr>
+        <p:spPr>
+          <a:xfrm>
+            <a:off x="0" y="1051560"/>
+            <a:ext cx="12191695" cy="38100"/>
+          </a:xfrm>
+          <a:prstGeom prst="rect">
+            <a:avLst/>
+          </a:prstGeom>
+          <a:solidFill>
+            <a:srgbClr val="2E5FA3"/>
+          </a:solidFill>
+          <a:ln>
+            <a:noFill/>
+          </a:ln>
+          <a:effectLst/>
+        </p:spPr>
+        <p:style>
+          <a:lnRef idx="1">
+            <a:schemeClr val="accent1"/>
+          </a:lnRef>
+          <a:fillRef idx="3">
+            <a:schemeClr val="accent1"/>
+          </a:fillRef>
+          <a:effectRef idx="2">
+            <a:schemeClr val="accent1"/>
+          </a:effectRef>
+          <a:fontRef idx="minor">
+            <a:schemeClr val="lt1"/>
+          </a:fontRef>
+        </p:style>
+        <p:txBody>
+          <a:bodyPr rtlCol="0" anchor="ctr"/>
+          <a:lstStyle/>
+          <a:p>
+            <a:pPr algn="ctr"/>
+          </a:p>
+        </p:txBody>
+      </p:sp>
+      <p:sp>
+        <p:nvSpPr>
+          <p:cNvPr id="4" name="TextBox 3"/>
+          <p:cNvSpPr txBox="1"/>
+          <p:nvPr/>
+        </p:nvSpPr>
+        <p:spPr>
+          <a:xfrm>
+            <a:off x="502920" y="109728"/>
+            <a:ext cx="9601200" cy="365760"/>
+          </a:xfrm>
+          <a:prstGeom prst="rect">
+            <a:avLst/>
+          </a:prstGeom>
+          <a:noFill/>
+        </p:spPr>
+        <p:txBody>
+          <a:bodyPr wrap="square" anchor="t">
+            <a:spAutoFit/>
+          </a:bodyPr>
+          <a:lstStyle/>
+          <a:p>
+            <a:pPr algn="l"/>
+            <a:r>
+              <a:rPr sz="1200" b="1" i="0">
+                <a:solidFill>
+                  <a:srgbClr val="AAC8EB"/>
+                </a:solidFill>
+                <a:latin typeface="Calibri"/>
+              </a:rPr>
+              <a:t>CONCLUSIONS</a:t>
+            </a:r>
+          </a:p>
+        </p:txBody>
+      </p:sp>
+      <p:sp>
+        <p:nvSpPr>
+          <p:cNvPr id="5" name="TextBox 4"/>
+          <p:cNvSpPr txBox="1"/>
+          <p:nvPr/>
+        </p:nvSpPr>
+        <p:spPr>
+          <a:xfrm>
+            <a:off x="502920" y="365760"/>
+            <a:ext cx="10607040" cy="640080"/>
+          </a:xfrm>
+          <a:prstGeom prst="rect">
+            <a:avLst/>
+          </a:prstGeom>
+          <a:noFill/>
+        </p:spPr>
+        <p:txBody>
+          <a:bodyPr wrap="square" anchor="t">
+            <a:spAutoFit/>
+          </a:bodyPr>
+          <a:lstStyle/>
+          <a:p>
+            <a:pPr algn="l"/>
+            <a:r>
+              <a:rPr sz="2600" b="1" i="0">
+                <a:solidFill>
+                  <a:srgbClr val="FFFFFF"/>
+                </a:solidFill>
+                <a:latin typeface="Calibri"/>
+              </a:rPr>
+              <a:t>Four takeaways</a:t>
+            </a:r>
+          </a:p>
+        </p:txBody>
+      </p:sp>
+      <p:sp>
+        <p:nvSpPr>
+          <p:cNvPr id="6" name="Rectangle 5"/>
+          <p:cNvSpPr/>
+          <p:nvPr/>
+        </p:nvSpPr>
+        <p:spPr>
+          <a:xfrm>
+            <a:off x="10058400" y="274320"/>
+            <a:ext cx="1737360" cy="457200"/>
+          </a:xfrm>
+          <a:prstGeom prst="rect">
+            <a:avLst/>
+          </a:prstGeom>
+          <a:solidFill>
+            <a:srgbClr val="2E5FA3"/>
+          </a:solidFill>
+          <a:ln>
+            <a:noFill/>
+          </a:ln>
+          <a:effectLst/>
+        </p:spPr>
+        <p:style>
+          <a:lnRef idx="1">
+            <a:schemeClr val="accent1"/>
+          </a:lnRef>
+          <a:fillRef idx="3">
+            <a:schemeClr val="accent1"/>
+          </a:fillRef>
+          <a:effectRef idx="2">
+            <a:schemeClr val="accent1"/>
+          </a:effectRef>
+          <a:fontRef idx="minor">
+            <a:schemeClr val="lt1"/>
+          </a:fontRef>
+        </p:style>
+        <p:txBody>
+          <a:bodyPr rtlCol="0" anchor="ctr"/>
+          <a:lstStyle/>
+          <a:p>
+            <a:pPr algn="ctr"/>
+          </a:p>
+        </p:txBody>
+      </p:sp>
+      <p:sp>
+        <p:nvSpPr>
+          <p:cNvPr id="7" name="TextBox 6"/>
+          <p:cNvSpPr txBox="1"/>
+          <p:nvPr/>
+        </p:nvSpPr>
+        <p:spPr>
+          <a:xfrm>
+            <a:off x="10058400" y="274320"/>
+            <a:ext cx="1737360" cy="457200"/>
+          </a:xfrm>
+          <a:prstGeom prst="rect">
+            <a:avLst/>
+          </a:prstGeom>
+          <a:noFill/>
+        </p:spPr>
+        <p:txBody>
+          <a:bodyPr wrap="square" anchor="ctr">
+            <a:spAutoFit/>
+          </a:bodyPr>
+          <a:lstStyle/>
+          <a:p>
+            <a:pPr algn="ctr"/>
+            <a:r>
+              <a:rPr sz="1300" b="1" i="0">
+                <a:solidFill>
+                  <a:srgbClr val="FFFFFF"/>
+                </a:solidFill>
+                <a:latin typeface="Calibri"/>
+              </a:rPr>
+              <a:t>LYAM</a:t>
+            </a:r>
+          </a:p>
+        </p:txBody>
+      </p:sp>
+      <p:sp>
+        <p:nvSpPr>
+          <p:cNvPr id="8" name="Rectangle 7"/>
+          <p:cNvSpPr/>
+          <p:nvPr/>
+        </p:nvSpPr>
+        <p:spPr>
+          <a:xfrm>
+            <a:off x="640080" y="1371600"/>
+            <a:ext cx="548640" cy="1051560"/>
+          </a:xfrm>
+          <a:prstGeom prst="rect">
+            <a:avLst/>
+          </a:prstGeom>
+          <a:solidFill>
+            <a:srgbClr val="003E7E"/>
+          </a:solidFill>
+          <a:ln>
+            <a:noFill/>
+          </a:ln>
+          <a:effectLst/>
+        </p:spPr>
+        <p:style>
+          <a:lnRef idx="1">
+            <a:schemeClr val="accent1"/>
+          </a:lnRef>
+          <a:fillRef idx="3">
+            <a:schemeClr val="accent1"/>
+          </a:fillRef>
+          <a:effectRef idx="2">
+            <a:schemeClr val="accent1"/>
+          </a:effectRef>
+          <a:fontRef idx="minor">
+            <a:schemeClr val="lt1"/>
+          </a:fontRef>
+        </p:style>
+        <p:txBody>
+          <a:bodyPr rtlCol="0" anchor="ctr"/>
+          <a:lstStyle/>
+          <a:p>
+            <a:pPr algn="ctr"/>
+          </a:p>
+        </p:txBody>
+      </p:sp>
+      <p:sp>
+        <p:nvSpPr>
+          <p:cNvPr id="9" name="TextBox 8"/>
+          <p:cNvSpPr txBox="1"/>
+          <p:nvPr/>
+        </p:nvSpPr>
+        <p:spPr>
+          <a:xfrm>
+            <a:off x="640080" y="1371600"/>
+            <a:ext cx="548640" cy="1051560"/>
+          </a:xfrm>
+          <a:prstGeom prst="rect">
+            <a:avLst/>
+          </a:prstGeom>
+          <a:noFill/>
+        </p:spPr>
+        <p:txBody>
+          <a:bodyPr wrap="square" anchor="ctr">
+            <a:spAutoFit/>
+          </a:bodyPr>
+          <a:lstStyle/>
+          <a:p>
+            <a:pPr algn="ctr"/>
+            <a:r>
+              <a:rPr sz="2400" b="1" i="0">
+                <a:solidFill>
+                  <a:srgbClr val="FFFFFF"/>
+                </a:solidFill>
+                <a:latin typeface="Calibri"/>
+              </a:rPr>
+              <a:t>1</a:t>
+            </a:r>
+          </a:p>
+        </p:txBody>
+      </p:sp>
+      <p:sp>
+        <p:nvSpPr>
+          <p:cNvPr id="10" name="Rectangle 9"/>
+          <p:cNvSpPr/>
+          <p:nvPr/>
+        </p:nvSpPr>
+        <p:spPr>
+          <a:xfrm>
+            <a:off x="1325880" y="1371600"/>
+            <a:ext cx="10195560" cy="1051560"/>
+          </a:xfrm>
+          <a:prstGeom prst="rect">
+            <a:avLst/>
+          </a:prstGeom>
+          <a:solidFill>
+            <a:srgbClr val="EEF3F9"/>
+          </a:solidFill>
+          <a:ln>
+            <a:noFill/>
+          </a:ln>
+          <a:effectLst/>
+        </p:spPr>
+        <p:style>
+          <a:lnRef idx="1">
+            <a:schemeClr val="accent1"/>
+          </a:lnRef>
+          <a:fillRef idx="3">
+            <a:schemeClr val="accent1"/>
+          </a:fillRef>
+          <a:effectRef idx="2">
+            <a:schemeClr val="accent1"/>
+          </a:effectRef>
+          <a:fontRef idx="minor">
+            <a:schemeClr val="lt1"/>
+          </a:fontRef>
+        </p:style>
+        <p:txBody>
+          <a:bodyPr rtlCol="0" anchor="ctr"/>
+          <a:lstStyle/>
+          <a:p>
+            <a:pPr algn="ctr"/>
+          </a:p>
+        </p:txBody>
+      </p:sp>
+      <p:sp>
+        <p:nvSpPr>
+          <p:cNvPr id="11" name="TextBox 10"/>
+          <p:cNvSpPr txBox="1"/>
+          <p:nvPr/>
+        </p:nvSpPr>
+        <p:spPr>
+          <a:xfrm>
+            <a:off x="1600200" y="1463040"/>
+            <a:ext cx="9784080" cy="914400"/>
+          </a:xfrm>
+          <a:prstGeom prst="rect">
+            <a:avLst/>
+          </a:prstGeom>
+          <a:noFill/>
+        </p:spPr>
+        <p:txBody>
+          <a:bodyPr wrap="square" anchor="t">
+            <a:spAutoFit/>
+          </a:bodyPr>
+          <a:lstStyle/>
+          <a:p>
+            <a:pPr algn="l"/>
+            <a:r>
+              <a:rPr sz="1700" b="1" i="0">
+                <a:solidFill>
+                  <a:srgbClr val="003E7E"/>
+                </a:solidFill>
+                <a:latin typeface="Calibri"/>
+              </a:rPr>
+              <a:t>ML beats naïve, decisively</a:t>
+            </a:r>
+          </a:p>
+          <a:p>
+            <a:pPr algn="l">
+              <a:spcBef>
+                <a:spcPts val="200"/>
+              </a:spcBef>
+            </a:pPr>
+            <a:r>
+              <a:rPr sz="1400" b="0" i="0">
+                <a:solidFill>
+                  <a:srgbClr val="212529"/>
+                </a:solidFill>
+                <a:latin typeface="Calibri"/>
+              </a:rPr>
+              <a:t>−49% MAE, R² 0.78, p &lt; 0.001 — robust across all 12 months.</a:t>
+            </a:r>
+          </a:p>
+        </p:txBody>
+      </p:sp>
+      <p:sp>
+        <p:nvSpPr>
+          <p:cNvPr id="12" name="Rectangle 11"/>
+          <p:cNvSpPr/>
+          <p:nvPr/>
+        </p:nvSpPr>
+        <p:spPr>
+          <a:xfrm>
+            <a:off x="640080" y="2596896"/>
+            <a:ext cx="548640" cy="1051560"/>
+          </a:xfrm>
+          <a:prstGeom prst="rect">
+            <a:avLst/>
+          </a:prstGeom>
+          <a:solidFill>
+            <a:srgbClr val="003E7E"/>
+          </a:solidFill>
+          <a:ln>
+            <a:noFill/>
+          </a:ln>
+          <a:effectLst/>
+        </p:spPr>
+        <p:style>
+          <a:lnRef idx="1">
+            <a:schemeClr val="accent1"/>
+          </a:lnRef>
+          <a:fillRef idx="3">
+            <a:schemeClr val="accent1"/>
+          </a:fillRef>
+          <a:effectRef idx="2">
+            <a:schemeClr val="accent1"/>
+          </a:effectRef>
+          <a:fontRef idx="minor">
+            <a:schemeClr val="lt1"/>
+          </a:fontRef>
+        </p:style>
+        <p:txBody>
+          <a:bodyPr rtlCol="0" anchor="ctr"/>
+          <a:lstStyle/>
+          <a:p>
+            <a:pPr algn="ctr"/>
+          </a:p>
+        </p:txBody>
+      </p:sp>
+      <p:sp>
+        <p:nvSpPr>
+          <p:cNvPr id="13" name="TextBox 12"/>
+          <p:cNvSpPr txBox="1"/>
+          <p:nvPr/>
+        </p:nvSpPr>
+        <p:spPr>
+          <a:xfrm>
+            <a:off x="640080" y="2596896"/>
+            <a:ext cx="548640" cy="1051560"/>
+          </a:xfrm>
+          <a:prstGeom prst="rect">
+            <a:avLst/>
+          </a:prstGeom>
+          <a:noFill/>
+        </p:spPr>
+        <p:txBody>
+          <a:bodyPr wrap="square" anchor="ctr">
+            <a:spAutoFit/>
+          </a:bodyPr>
+          <a:lstStyle/>
+          <a:p>
+            <a:pPr algn="ctr"/>
+            <a:r>
+              <a:rPr sz="2400" b="1" i="0">
+                <a:solidFill>
+                  <a:srgbClr val="FFFFFF"/>
+                </a:solidFill>
+                <a:latin typeface="Calibri"/>
+              </a:rPr>
+              <a:t>2</a:t>
+            </a:r>
+          </a:p>
+        </p:txBody>
+      </p:sp>
+      <p:sp>
+        <p:nvSpPr>
+          <p:cNvPr id="14" name="Rectangle 13"/>
+          <p:cNvSpPr/>
+          <p:nvPr/>
+        </p:nvSpPr>
+        <p:spPr>
+          <a:xfrm>
+            <a:off x="1325880" y="2596896"/>
+            <a:ext cx="10195560" cy="1051560"/>
+          </a:xfrm>
+          <a:prstGeom prst="rect">
+            <a:avLst/>
+          </a:prstGeom>
+          <a:solidFill>
+            <a:srgbClr val="EEF3F9"/>
+          </a:solidFill>
+          <a:ln>
+            <a:noFill/>
+          </a:ln>
+          <a:effectLst/>
+        </p:spPr>
+        <p:style>
+          <a:lnRef idx="1">
+            <a:schemeClr val="accent1"/>
+          </a:lnRef>
+          <a:fillRef idx="3">
+            <a:schemeClr val="accent1"/>
+          </a:fillRef>
+          <a:effectRef idx="2">
+            <a:schemeClr val="accent1"/>
+          </a:effectRef>
+          <a:fontRef idx="minor">
+            <a:schemeClr val="lt1"/>
+          </a:fontRef>
+        </p:style>
+        <p:txBody>
+          <a:bodyPr rtlCol="0" anchor="ctr"/>
+          <a:lstStyle/>
+          <a:p>
+            <a:pPr algn="ctr"/>
+          </a:p>
+        </p:txBody>
+      </p:sp>
+      <p:sp>
+        <p:nvSpPr>
+          <p:cNvPr id="15" name="TextBox 14"/>
+          <p:cNvSpPr txBox="1"/>
+          <p:nvPr/>
+        </p:nvSpPr>
+        <p:spPr>
+          <a:xfrm>
+            <a:off x="1600200" y="2688336"/>
+            <a:ext cx="9784080" cy="914400"/>
+          </a:xfrm>
+          <a:prstGeom prst="rect">
+            <a:avLst/>
+          </a:prstGeom>
+          <a:noFill/>
+        </p:spPr>
+        <p:txBody>
+          <a:bodyPr wrap="square" anchor="t">
+            <a:spAutoFit/>
+          </a:bodyPr>
+          <a:lstStyle/>
+          <a:p>
+            <a:pPr algn="l"/>
+            <a:r>
+              <a:rPr sz="1700" b="1" i="0">
+                <a:solidFill>
+                  <a:srgbClr val="003E7E"/>
+                </a:solidFill>
+                <a:latin typeface="Calibri"/>
+              </a:rPr>
+              <a:t>Weather is regime-dependent</a:t>
+            </a:r>
+          </a:p>
+          <a:p>
+            <a:pPr algn="l">
+              <a:spcBef>
+                <a:spcPts val="200"/>
+              </a:spcBef>
+            </a:pPr>
+            <a:r>
+              <a:rPr sz="1400" b="0" i="0">
+                <a:solidFill>
+                  <a:srgbClr val="212529"/>
+                </a:solidFill>
+                <a:latin typeface="Calibri"/>
+              </a:rPr>
+              <a:t>n.s. in the stable regime (redundancy), but significant in the 2022 crisis (redundancy breaks). The core contribution.</a:t>
+            </a:r>
+          </a:p>
+        </p:txBody>
+      </p:sp>
+      <p:sp>
+        <p:nvSpPr>
+          <p:cNvPr id="16" name="Rectangle 15"/>
+          <p:cNvSpPr/>
+          <p:nvPr/>
+        </p:nvSpPr>
+        <p:spPr>
+          <a:xfrm>
+            <a:off x="640080" y="3822192"/>
+            <a:ext cx="548640" cy="1051560"/>
+          </a:xfrm>
+          <a:prstGeom prst="rect">
+            <a:avLst/>
+          </a:prstGeom>
+          <a:solidFill>
+            <a:srgbClr val="003E7E"/>
+          </a:solidFill>
+          <a:ln>
+            <a:noFill/>
+          </a:ln>
+          <a:effectLst/>
+        </p:spPr>
+        <p:style>
+          <a:lnRef idx="1">
+            <a:schemeClr val="accent1"/>
+          </a:lnRef>
+          <a:fillRef idx="3">
+            <a:schemeClr val="accent1"/>
+          </a:fillRef>
+          <a:effectRef idx="2">
+            <a:schemeClr val="accent1"/>
+          </a:effectRef>
+          <a:fontRef idx="minor">
+            <a:schemeClr val="lt1"/>
+          </a:fontRef>
+        </p:style>
+        <p:txBody>
+          <a:bodyPr rtlCol="0" anchor="ctr"/>
+          <a:lstStyle/>
+          <a:p>
+            <a:pPr algn="ctr"/>
+          </a:p>
+        </p:txBody>
+      </p:sp>
+      <p:sp>
+        <p:nvSpPr>
+          <p:cNvPr id="17" name="TextBox 16"/>
+          <p:cNvSpPr txBox="1"/>
+          <p:nvPr/>
+        </p:nvSpPr>
+        <p:spPr>
+          <a:xfrm>
+            <a:off x="640080" y="3822192"/>
+            <a:ext cx="548640" cy="1051560"/>
+          </a:xfrm>
+          <a:prstGeom prst="rect">
+            <a:avLst/>
+          </a:prstGeom>
+          <a:noFill/>
+        </p:spPr>
+        <p:txBody>
+          <a:bodyPr wrap="square" anchor="ctr">
+            <a:spAutoFit/>
+          </a:bodyPr>
+          <a:lstStyle/>
+          <a:p>
+            <a:pPr algn="ctr"/>
+            <a:r>
+              <a:rPr sz="2400" b="1" i="0">
+                <a:solidFill>
+                  <a:srgbClr val="FFFFFF"/>
+                </a:solidFill>
+                <a:latin typeface="Calibri"/>
+              </a:rPr>
+              <a:t>3</a:t>
+            </a:r>
+          </a:p>
+        </p:txBody>
+      </p:sp>
+      <p:sp>
+        <p:nvSpPr>
+          <p:cNvPr id="18" name="Rectangle 17"/>
+          <p:cNvSpPr/>
+          <p:nvPr/>
+        </p:nvSpPr>
+        <p:spPr>
+          <a:xfrm>
+            <a:off x="1325880" y="3822192"/>
+            <a:ext cx="10195560" cy="1051560"/>
+          </a:xfrm>
+          <a:prstGeom prst="rect">
+            <a:avLst/>
+          </a:prstGeom>
+          <a:solidFill>
+            <a:srgbClr val="EEF3F9"/>
+          </a:solidFill>
+          <a:ln>
+            <a:noFill/>
+          </a:ln>
+          <a:effectLst/>
+        </p:spPr>
+        <p:style>
+          <a:lnRef idx="1">
+            <a:schemeClr val="accent1"/>
+          </a:lnRef>
+          <a:fillRef idx="3">
+            <a:schemeClr val="accent1"/>
+          </a:fillRef>
+          <a:effectRef idx="2">
+            <a:schemeClr val="accent1"/>
+          </a:effectRef>
+          <a:fontRef idx="minor">
+            <a:schemeClr val="lt1"/>
+          </a:fontRef>
+        </p:style>
+        <p:txBody>
+          <a:bodyPr rtlCol="0" anchor="ctr"/>
+          <a:lstStyle/>
+          <a:p>
+            <a:pPr algn="ctr"/>
+          </a:p>
+        </p:txBody>
+      </p:sp>
+      <p:sp>
+        <p:nvSpPr>
+          <p:cNvPr id="19" name="TextBox 18"/>
+          <p:cNvSpPr txBox="1"/>
+          <p:nvPr/>
+        </p:nvSpPr>
+        <p:spPr>
+          <a:xfrm>
+            <a:off x="1600200" y="3913632"/>
+            <a:ext cx="9784080" cy="914400"/>
+          </a:xfrm>
+          <a:prstGeom prst="rect">
+            <a:avLst/>
+          </a:prstGeom>
+          <a:noFill/>
+        </p:spPr>
+        <p:txBody>
+          <a:bodyPr wrap="square" anchor="t">
+            <a:spAutoFit/>
+          </a:bodyPr>
+          <a:lstStyle/>
+          <a:p>
+            <a:pPr algn="l"/>
+            <a:r>
+              <a:rPr sz="1700" b="1" i="0">
+                <a:solidFill>
+                  <a:srgbClr val="003E7E"/>
+                </a:solidFill>
+                <a:latin typeface="Calibri"/>
+              </a:rPr>
+              <a:t>Random Forest &gt; XGBoost</a:t>
+            </a:r>
+          </a:p>
+          <a:p>
+            <a:pPr algn="l">
+              <a:spcBef>
+                <a:spcPts val="200"/>
+              </a:spcBef>
+            </a:pPr>
+            <a:r>
+              <a:rPr sz="1400" b="0" i="0">
+                <a:solidFill>
+                  <a:srgbClr val="212529"/>
+                </a:solidFill>
+                <a:latin typeface="Calibri"/>
+              </a:rPr>
+              <a:t>RF wins on risk-adjusted metrics (Calmar 328 vs 107) and degrades less under stress.</a:t>
+            </a:r>
+          </a:p>
+        </p:txBody>
+      </p:sp>
+      <p:sp>
+        <p:nvSpPr>
+          <p:cNvPr id="20" name="Rectangle 19"/>
+          <p:cNvSpPr/>
+          <p:nvPr/>
+        </p:nvSpPr>
+        <p:spPr>
+          <a:xfrm>
+            <a:off x="640080" y="5047488"/>
+            <a:ext cx="548640" cy="1051560"/>
+          </a:xfrm>
+          <a:prstGeom prst="rect">
+            <a:avLst/>
+          </a:prstGeom>
+          <a:solidFill>
+            <a:srgbClr val="003E7E"/>
+          </a:solidFill>
+          <a:ln>
+            <a:noFill/>
+          </a:ln>
+          <a:effectLst/>
+        </p:spPr>
+        <p:style>
+          <a:lnRef idx="1">
+            <a:schemeClr val="accent1"/>
+          </a:lnRef>
+          <a:fillRef idx="3">
+            <a:schemeClr val="accent1"/>
+          </a:fillRef>
+          <a:effectRef idx="2">
+            <a:schemeClr val="accent1"/>
+          </a:effectRef>
+          <a:fontRef idx="minor">
+            <a:schemeClr val="lt1"/>
+          </a:fontRef>
+        </p:style>
+        <p:txBody>
+          <a:bodyPr rtlCol="0" anchor="ctr"/>
+          <a:lstStyle/>
+          <a:p>
+            <a:pPr algn="ctr"/>
+          </a:p>
+        </p:txBody>
+      </p:sp>
+      <p:sp>
+        <p:nvSpPr>
+          <p:cNvPr id="21" name="TextBox 20"/>
+          <p:cNvSpPr txBox="1"/>
+          <p:nvPr/>
+        </p:nvSpPr>
+        <p:spPr>
+          <a:xfrm>
+            <a:off x="640080" y="5047488"/>
+            <a:ext cx="548640" cy="1051560"/>
+          </a:xfrm>
+          <a:prstGeom prst="rect">
+            <a:avLst/>
+          </a:prstGeom>
+          <a:noFill/>
+        </p:spPr>
+        <p:txBody>
+          <a:bodyPr wrap="square" anchor="ctr">
+            <a:spAutoFit/>
+          </a:bodyPr>
+          <a:lstStyle/>
+          <a:p>
+            <a:pPr algn="ctr"/>
+            <a:r>
+              <a:rPr sz="2400" b="1" i="0">
+                <a:solidFill>
+                  <a:srgbClr val="FFFFFF"/>
+                </a:solidFill>
+                <a:latin typeface="Calibri"/>
+              </a:rPr>
+              <a:t>4</a:t>
+            </a:r>
+          </a:p>
+        </p:txBody>
+      </p:sp>
+      <p:sp>
+        <p:nvSpPr>
+          <p:cNvPr id="22" name="Rectangle 21"/>
+          <p:cNvSpPr/>
+          <p:nvPr/>
+        </p:nvSpPr>
+        <p:spPr>
+          <a:xfrm>
+            <a:off x="1325880" y="5047488"/>
+            <a:ext cx="10195560" cy="1051560"/>
+          </a:xfrm>
+          <a:prstGeom prst="rect">
+            <a:avLst/>
+          </a:prstGeom>
+          <a:solidFill>
+            <a:srgbClr val="EEF3F9"/>
+          </a:solidFill>
+          <a:ln>
+            <a:noFill/>
+          </a:ln>
+          <a:effectLst/>
+        </p:spPr>
+        <p:style>
+          <a:lnRef idx="1">
+            <a:schemeClr val="accent1"/>
+          </a:lnRef>
+          <a:fillRef idx="3">
+            <a:schemeClr val="accent1"/>
+          </a:fillRef>
+          <a:effectRef idx="2">
+            <a:schemeClr val="accent1"/>
+          </a:effectRef>
+          <a:fontRef idx="minor">
+            <a:schemeClr val="lt1"/>
+          </a:fontRef>
+        </p:style>
+        <p:txBody>
+          <a:bodyPr rtlCol="0" anchor="ctr"/>
+          <a:lstStyle/>
+          <a:p>
+            <a:pPr algn="ctr"/>
+          </a:p>
+        </p:txBody>
+      </p:sp>
+      <p:sp>
+        <p:nvSpPr>
+          <p:cNvPr id="23" name="TextBox 22"/>
+          <p:cNvSpPr txBox="1"/>
+          <p:nvPr/>
+        </p:nvSpPr>
+        <p:spPr>
+          <a:xfrm>
+            <a:off x="1600200" y="5138928"/>
+            <a:ext cx="9784080" cy="914400"/>
+          </a:xfrm>
+          <a:prstGeom prst="rect">
+            <a:avLst/>
+          </a:prstGeom>
+          <a:noFill/>
+        </p:spPr>
+        <p:txBody>
+          <a:bodyPr wrap="square" anchor="t">
+            <a:spAutoFit/>
+          </a:bodyPr>
+          <a:lstStyle/>
+          <a:p>
+            <a:pPr algn="l"/>
+            <a:r>
+              <a:rPr sz="1700" b="1" i="0">
+                <a:solidFill>
+                  <a:srgbClr val="003E7E"/>
+                </a:solidFill>
+                <a:latin typeface="Calibri"/>
+              </a:rPr>
+              <a:t>Forecasts create real value</a:t>
+            </a:r>
+          </a:p>
+          <a:p>
+            <a:pPr algn="l">
+              <a:spcBef>
+                <a:spcPts val="200"/>
+              </a:spcBef>
+            </a:pPr>
+            <a:r>
+              <a:rPr sz="1400" b="0" i="0">
+                <a:solidFill>
+                  <a:srgbClr val="212529"/>
+                </a:solidFill>
+                <a:latin typeface="Calibri"/>
+              </a:rPr>
+              <a:t>~137k EUR/MW net, Sharpe ~19.5, tiny drawdown — robust to transaction costs.</a:t>
+            </a:r>
+          </a:p>
+        </p:txBody>
+      </p:sp>
+      <p:sp>
+        <p:nvSpPr>
+          <p:cNvPr id="24" name="TextBox 23"/>
+          <p:cNvSpPr txBox="1"/>
+          <p:nvPr/>
+        </p:nvSpPr>
+        <p:spPr>
+          <a:xfrm>
+            <a:off x="457200" y="6446520"/>
+            <a:ext cx="7315200" cy="320040"/>
+          </a:xfrm>
+          <a:prstGeom prst="rect">
+            <a:avLst/>
+          </a:prstGeom>
+          <a:noFill/>
+        </p:spPr>
+        <p:txBody>
+          <a:bodyPr wrap="square" anchor="t">
+            <a:spAutoFit/>
+          </a:bodyPr>
+          <a:lstStyle/>
+          <a:p>
+            <a:pPr algn="l"/>
+            <a:r>
+              <a:rPr sz="900" b="0" i="0">
+                <a:solidFill>
+                  <a:srgbClr val="6E6E6E"/>
+                </a:solidFill>
+                <a:latin typeface="Calibri"/>
+              </a:rPr>
+              <a:t>Weather in French Day-Ahead Electricity Price Forecasting</a:t>
+            </a:r>
+          </a:p>
+        </p:txBody>
+      </p:sp>
+      <p:sp>
+        <p:nvSpPr>
+          <p:cNvPr id="25" name="TextBox 24"/>
+          <p:cNvSpPr txBox="1"/>
+          <p:nvPr/>
+        </p:nvSpPr>
+        <p:spPr>
+          <a:xfrm>
+            <a:off x="10972800" y="6446520"/>
+            <a:ext cx="822960" cy="320040"/>
+          </a:xfrm>
+          <a:prstGeom prst="rect">
+            <a:avLst/>
+          </a:prstGeom>
+          <a:noFill/>
+        </p:spPr>
+        <p:txBody>
+          <a:bodyPr wrap="square" anchor="t">
+            <a:spAutoFit/>
+          </a:bodyPr>
+          <a:lstStyle/>
+          <a:p>
+            <a:pPr algn="r"/>
+            <a:r>
+              <a:rPr sz="1100" b="1" i="0">
+                <a:solidFill>
+                  <a:srgbClr val="003E7E"/>
+                </a:solidFill>
+                <a:latin typeface="Calibri"/>
+              </a:rPr>
+              <a:t>15</a:t>
+            </a:r>
+          </a:p>
+        </p:txBody>
+      </p:sp>
+    </p:spTree>
+  </p:cSld>
+  <p:clrMapOvr>
+    <a:masterClrMapping/>
+  </p:clrMapOvr>
+</p:sld>
+</file>
+
+<file path=ppt/slides/slide16.xml><?xml version="1.0" encoding="utf-8"?>
 <p:sld xmlns:a="http://schemas.openxmlformats.org/drawingml/2006/main" xmlns:p="http://schemas.openxmlformats.org/presentationml/2006/main" xmlns:r="http://schemas.openxmlformats.org/officeDocument/2006/relationships">
   <p:cSld>
     <p:spTree>

</xml_diff>